<commit_message>
W02/D3: learner files stop naming the Retail-Plus plants
The afternoon debrief shows the room's own counts, the study notes teach the tie rule without the
segment, the falling-spend split by segment is gone, and the provenance note says what the pack
now does. The study notes also lose their adverbial however.

Co-Authored-By: Claude Opus 5.5 <noreply@anthropic.com>
Claude-Session: https://claude.ai/code/session_01TqMoycMRvWSVphHv5tXoPT
</commit_message>
<xml_diff>
--- a/content/W02/D3/slides/C2_W02_D03_half2_STUDENT.pptx
+++ b/content/W02/D3/slides/C2_W02_D03_half2_STUDENT.pptx
@@ -771,17 +771,17 @@
           </a:p>
           <a:p>
             <a:r>
-              <a:t>right and is the dangerous one: which of the tied pair ships depends on the tiebreaker, so a member</a:t>
-            </a:r>
-          </a:p>
-          <a:p>
-            <a:r>
-              <a:t>can be on Monday's list and off Tuesday's with the same spend. Interview [F] follow-up: your top</a:t>
-            </a:r>
-          </a:p>
-          <a:p>
-            <a:r>
-              <a:t>fifty came back with 51 rows; it is no bug, and the stakeholder is told the tie and the count.</a:t>
+              <a:t>right and is the dangerous one: which member at the line ships depends on the tiebreaker, so a</a:t>
+            </a:r>
+          </a:p>
+          <a:p>
+            <a:r>
+              <a:t>member can be on Monday's list and off Tuesday's with the same spend. Interview [F] follow-up: your</a:t>
+            </a:r>
+          </a:p>
+          <a:p>
+            <a:r>
+              <a:t>top ten came back with eleven rows; it is no bug, and the stakeholder is told the tie and the count.</a:t>
             </a:r>
           </a:p>
         </p:txBody>
@@ -8100,7 +8100,7 @@
                 </a:solidFill>
                 <a:latin typeface="Georgia"/>
               </a:rPr>
-              <a:t>Answer: 51, with RANK, and the line says why</a:t>
+              <a:t>Answer: RANK's count, and the line says why</a:t>
             </a:r>
           </a:p>
         </p:txBody>
@@ -8135,7 +8135,7 @@
                 </a:solidFill>
                 <a:latin typeface="Calibri"/>
               </a:rPr>
-              <a:t>Two Retail-Plus members tie at fiftieth, so RANK keeps both and ships fifty-one.</a:t>
+              <a:t>The room's four counts came from four rules, and the one to ship is the count RANK returned.</a:t>
             </a:r>
           </a:p>
         </p:txBody>
@@ -8150,7 +8150,7 @@
         </p:nvGraphicFramePr>
         <p:xfrm>
           <a:off x="530352" y="1956816"/>
-          <a:ext cx="11130989" cy="1849120"/>
+          <a:ext cx="11130989" cy="2574544"/>
         </p:xfrm>
         <a:graphic>
           <a:graphicData uri="http://schemas.openxmlformats.org/drawingml/2006/table">
@@ -8159,9 +8159,9 @@
                 <a:tableStyleId>{2D5ABB26-0587-4C30-8999-92F81FD0307C}</a:tableStyleId>
               </a:tblPr>
               <a:tblGrid>
-                <a:gridCol w="2472044"/>
-                <a:gridCol w="2264852"/>
-                <a:gridCol w="6394093"/>
+                <a:gridCol w="2498621"/>
+                <a:gridCol w="2169533"/>
+                <a:gridCol w="6462835"/>
               </a:tblGrid>
               <a:tr h="369824">
                 <a:tc>
@@ -8198,7 +8198,7 @@
                           </a:solidFill>
                           <a:latin typeface="Calibri"/>
                         </a:rPr>
-                        <a:t>Retail-Plus ships</a:t>
+                        <a:t>The room's count</a:t>
                       </a:r>
                     </a:p>
                   </a:txBody>
@@ -8220,7 +8220,7 @@
                           </a:solidFill>
                           <a:latin typeface="Calibri"/>
                         </a:rPr>
-                        <a:t>What it did at the line</a:t>
+                        <a:t>What the rule did at the line, in the room's files</a:t>
                       </a:r>
                     </a:p>
                   </a:txBody>
@@ -8231,7 +8231,7 @@
                   </a:tcPr>
                 </a:tc>
               </a:tr>
-              <a:tr h="369824">
+              <a:tr h="611632">
                 <a:tc>
                   <a:txBody>
                     <a:bodyPr/>
@@ -8288,7 +8288,7 @@
                           </a:solidFill>
                           <a:latin typeface="Calibri"/>
                         </a:rPr>
-                        <a:t>Both tied members kept, which is what the head asked</a:t>
+                        <a:t>Every member sharing the last position kept, which is what the head asked</a:t>
                       </a:r>
                     </a:p>
                   </a:txBody>
@@ -8299,7 +8299,7 @@
                   </a:tcPr>
                 </a:tc>
               </a:tr>
-              <a:tr h="369824">
+              <a:tr h="611632">
                 <a:tc>
                   <a:txBody>
                     <a:bodyPr/>
@@ -8356,7 +8356,7 @@
                           </a:solidFill>
                           <a:latin typeface="Calibri"/>
                         </a:rPr>
-                        <a:t>Both tied members dropped, the forty-nine he forbade</a:t>
+                        <a:t>The members sharing the last position all dropped, the forty-nine he forbade</a:t>
                       </a:r>
                     </a:p>
                   </a:txBody>
@@ -8424,7 +8424,7 @@
                           </a:solidFill>
                           <a:latin typeface="Calibri"/>
                         </a:rPr>
-                        <a:t>One tied member dropped by the database's choice</a:t>
+                        <a:t>One member at the last position dropped by the database's choice</a:t>
                       </a:r>
                     </a:p>
                   </a:txBody>
@@ -8435,7 +8435,7 @@
                   </a:tcPr>
                 </a:tc>
               </a:tr>
-              <a:tr h="369824">
+              <a:tr h="611632">
                 <a:tc>
                   <a:txBody>
                     <a:bodyPr/>
@@ -8492,7 +8492,7 @@
                           </a:solidFill>
                           <a:latin typeface="Calibri"/>
                         </a:rPr>
-                        <a:t>A tie higher up saved a number, so a member past the line ships</a:t>
+                        <a:t>A shared position higher up saved a number, so a member past the line ships</a:t>
                       </a:r>
                     </a:p>
                   </a:txBody>
@@ -8515,7 +8515,7 @@
         </p:nvSpPr>
         <p:spPr>
           <a:xfrm>
-            <a:off x="530352" y="4061968"/>
+            <a:off x="530352" y="4787392"/>
             <a:ext cx="11130991" cy="1121664"/>
           </a:xfrm>
           <a:prstGeom prst="roundRect">
@@ -8569,7 +8569,7 @@
         </p:nvSpPr>
         <p:spPr>
           <a:xfrm>
-            <a:off x="758952" y="4394200"/>
+            <a:off x="758952" y="5119624"/>
             <a:ext cx="457200" cy="457200"/>
           </a:xfrm>
           <a:prstGeom prst="ellipse">
@@ -8621,7 +8621,7 @@
         </p:blipFill>
         <p:spPr>
           <a:xfrm>
-            <a:off x="868680" y="4503928"/>
+            <a:off x="868680" y="5229352"/>
             <a:ext cx="237744" cy="237744"/>
           </a:xfrm>
           <a:prstGeom prst="rect">
@@ -8637,7 +8637,7 @@
         </p:nvSpPr>
         <p:spPr>
           <a:xfrm>
-            <a:off x="1399031" y="4208272"/>
+            <a:off x="1399031" y="4933696"/>
             <a:ext cx="9987991" cy="160401"/>
           </a:xfrm>
           <a:prstGeom prst="rect">
@@ -8672,7 +8672,7 @@
         </p:nvSpPr>
         <p:spPr>
           <a:xfrm>
-            <a:off x="1399031" y="4427728"/>
+            <a:off x="1399031" y="5153152"/>
             <a:ext cx="9987991" cy="682752"/>
           </a:xfrm>
           <a:prstGeom prst="rect">
@@ -8693,7 +8693,7 @@
                 </a:solidFill>
                 <a:latin typeface="Calibri"/>
               </a:rPr>
-              <a:t>Fifty-one is correct, and it is only defensible with its reason beside it: "51 Retail-Plus members, because two tie at fiftieth."</a:t>
+              <a:t>The RANK count is correct, and it is only defensible with its reason beside it, read from your own file: count the members at the last position and say it in the same line as the count.</a:t>
             </a:r>
           </a:p>
         </p:txBody>
@@ -9421,7 +9421,7 @@
                 </a:solidFill>
                 <a:latin typeface="Calibri"/>
               </a:rPr>
-              <a:t>A month with no order is no reading, so it breaks the run. Nine listed members spent less in August than July and less again in September, three each in Business, Retail-Core and Retail-Plus.</a:t>
+              <a:t>A month with no order is no reading, so it breaks the run. Nine listed members spent less in August than July and less again in September.</a:t>
             </a:r>
           </a:p>
         </p:txBody>
@@ -10742,7 +10742,7 @@
                 </a:solidFill>
                 <a:latin typeface="Georgia"/>
               </a:rPr>
-              <a:t>"We ranked with RANK inside each segment, so tied members share a place and nobody at the line is dropped by a coin toss: the list carries 35 Business and 20 Student members, which is every Q2 buyer there, 50 Retail-Core and 51 Retail-Plus, because two Retail-Plus members tie at fiftieth. Nine listed members spent less in August than July and less again in September; a member with no August order is not flagged, because a month without an order is no reading. Q2 closed on plan, Rs 9,84,00,000 against Rs 9,83,99,990, and the Rs 1.58 crore lead at mid-quarter came from one week in July, so the weekly run rate has been below plan since 10 August."</a:t>
+              <a:t>"We ranked with RANK inside each segment, so tied members share a place and nobody at the line is dropped by a coin toss: the list carries 35 Business and 20 Student members, which is every Q2 buyer there, 50 Retail-Core and 51 Retail-Plus, where our RANK file shows two members sharing the fiftieth place. Nine listed members spent less in August than July and less again in September; a member with no August order is not flagged, because a month without an order is no reading. Q2 closed on plan, Rs 9,84,00,000 against Rs 9,83,99,990, and the Rs 1.58 crore lead at mid-quarter came from one week in July, so the weekly run rate has been below plan since 10 August."</a:t>
             </a:r>
           </a:p>
         </p:txBody>
@@ -11490,7 +11490,7 @@
                 </a:solidFill>
                 <a:latin typeface="Calibri"/>
               </a:rPr>
-              <a:t>Week 2 Wednesday: the case and the close</a:t>
+              <a:t>Week 2, Day 3. Marketing's Monday file, and the sentence on it</a:t>
             </a:r>
           </a:p>
         </p:txBody>
@@ -16074,7 +16074,7 @@
                 </a:solidFill>
                 <a:latin typeface="Calibri"/>
               </a:rPr>
-              <a:t>Week 2 Wednesday: the case and the close</a:t>
+              <a:t>Week 2, Day 3. Marketing's Monday file, and the sentence on it</a:t>
             </a:r>
           </a:p>
         </p:txBody>
@@ -22361,7 +22361,7 @@
                 </a:solidFill>
                 <a:latin typeface="Calibri"/>
               </a:rPr>
-              <a:t>Week 2 Wednesday: the case and the close</a:t>
+              <a:t>Week 2, Day 3. Marketing's Monday file, and the sentence on it</a:t>
             </a:r>
           </a:p>
         </p:txBody>

</xml_diff>

<commit_message>
W02 D3 reading family and the first humanizer read: study notes of about 5,000 words on the six chapters with thirteen interview answers, a one-page cheat sheet whose anchor is the day's picture, nineteen board drawings in the order they go up, Thursday's pre-read and the tiered extras; the decks, notebook markdown, day sheet, lab note and SQL comments read in file mode, with every pronoun for a member or an unnamed stakeholder made they; each chapter notebook points to its retail dossier section; the drill splits across D22 and D23 so all thirteen questions print; notebooks re-executed cold and decks rebuilt on mermaid-cli 11.17.0
Co-Authored-By: Claude Opus 5.5 <noreply@anthropic.com>
Claude-Session: https://claude.ai/code/session_01EV1dpeTc9EdycAQ9bsiTNd
</commit_message>
<xml_diff>
--- a/content/W02/D3/slides/C2_W02_D03_half2_STUDENT.pptx
+++ b/content/W02/D3/slides/C2_W02_D03_half2_STUDENT.pptx
@@ -34,6 +34,7 @@
     <p:sldId id="282" r:id="rId34"/>
     <p:sldId id="283" r:id="rId35"/>
     <p:sldId id="284" r:id="rId36"/>
+    <p:sldId id="285" r:id="rId37"/>
   </p:sldIdLst>
   <p:sldSz cx="12191695" cy="6858000" type="screen4x3"/>
   <p:notesSz cx="6858000" cy="9144000"/>
@@ -690,7 +691,7 @@
           <a:lstStyle/>
           <a:p>
             <a:r>
-              <a:t>LIVE, 2 minutes. Read his row aloud: three months with orders and three without. Letters in chat.</a:t>
+              <a:t>LIVE, 2 minutes. Read C-0216's row aloud: three months with orders and three without. Letters in chat.</a:t>
             </a:r>
           </a:p>
           <a:p>
@@ -1535,12 +1536,12 @@
           <a:lstStyle/>
           <a:p>
             <a:r>
-              <a:t>LIVE, 2 minutes. These are the morning's rules, not the case's answers. Then go: seventeen</a:t>
-            </a:r>
-          </a:p>
-          <a:p>
-            <a:r>
-              <a:t>minutes, parts 1 and 2. After the case, the close.</a:t>
+              <a:t>LIVE, 2 minutes. The cards repeat the morning's rules and give away none of the case's answers.</a:t>
+            </a:r>
+          </a:p>
+          <a:p>
+            <a:r>
+              <a:t>Then go: seventeen minutes, parts 1 and 2. After the case, the close.</a:t>
             </a:r>
           </a:p>
         </p:txBody>
@@ -1905,17 +1906,22 @@
           <a:lstStyle/>
           <a:p>
             <a:r>
-              <a:t>SELF-STUDY, and the practice lab's drill. [S] is a staple asked everywhere, [F] frequent at global</a:t>
-            </a:r>
-          </a:p>
-          <a:p>
-            <a:r>
-              <a:t>capability centres and product companies, [D] a differentiator. Each question is answered in full in</a:t>
-            </a:r>
-          </a:p>
-          <a:p>
-            <a:r>
-              <a:t>its chapter's notebook and in the study notes; in the lab, pairs ask each other aloud.</a:t>
+              <a:t>SELF-STUDY, and the practice lab's drill. [S] is a staple asked everywhere and [F] frequent at global</a:t>
+            </a:r>
+          </a:p>
+          <a:p>
+            <a:r>
+              <a:t>capability centres and product companies; D23 carries the three differentiators. Each question is</a:t>
+            </a:r>
+          </a:p>
+          <a:p>
+            <a:r>
+              <a:t>answered in full in its chapter's notebook and in the study notes; in the lab, pairs ask each other</a:t>
+            </a:r>
+          </a:p>
+          <a:p>
+            <a:r>
+              <a:t>aloud.</a:t>
             </a:r>
           </a:p>
         </p:txBody>
@@ -1985,17 +1991,12 @@
           <a:lstStyle/>
           <a:p>
             <a:r>
-              <a:t>SELF-STUDY, in pairs or alone, about forty minutes. The notebook is</a:t>
-            </a:r>
-          </a:p>
-          <a:p>
-            <a:r>
-              <a:t>notebooks/C2_W02_D03_ex2_second_case_STUDENT.ipynb and the brief</a:t>
-            </a:r>
-          </a:p>
-          <a:p>
-            <a:r>
-              <a:t>exercises/unguided/C2_W02_D03_second_case_STUDENT.md.</a:t>
+              <a:t>SELF-STUDY, and the practice lab's drill, asked last. [D] marks a differentiator. The answers are in</a:t>
+            </a:r>
+          </a:p>
+          <a:p>
+            <a:r>
+              <a:t>chapter 3's, chapter 6's and chapter 5's notebooks and in the study notes.</a:t>
             </a:r>
           </a:p>
         </p:txBody>
@@ -2065,12 +2066,17 @@
           <a:lstStyle/>
           <a:p>
             <a:r>
-              <a:t>SELF-STUDY, and the lab's debrief of the room's wrong answers. Each line is a trap the day staged on</a:t>
-            </a:r>
-          </a:p>
-          <a:p>
-            <a:r>
-              <a:t>purpose; the room met each one before its name.</a:t>
+              <a:t>SELF-STUDY, in pairs or alone, about forty minutes. The notebook is</a:t>
+            </a:r>
+          </a:p>
+          <a:p>
+            <a:r>
+              <a:t>notebooks/C2_W02_D03_ex2_second_case_STUDENT.ipynb and the brief</a:t>
+            </a:r>
+          </a:p>
+          <a:p>
+            <a:r>
+              <a:t>exercises/unguided/C2_W02_D03_second_case_STUDENT.md.</a:t>
             </a:r>
           </a:p>
         </p:txBody>
@@ -2140,12 +2146,12 @@
           <a:lstStyle/>
           <a:p>
             <a:r>
-              <a:t>LIVE, 1 minute. Read it and leave it open: today's flag becomes a column of tomorrow's table. The</a:t>
-            </a:r>
-          </a:p>
-          <a:p>
-            <a:r>
-              <a:t>pre-read for Thursday ships tonight. Then the tentative IITGN block.</a:t>
+              <a:t>SELF-STUDY, and the lab's debrief of the room's wrong answers. Each line is a trap the day staged on</a:t>
+            </a:r>
+          </a:p>
+          <a:p>
+            <a:r>
+              <a:t>purpose, and the room met each wrong number before anyone named the mistake.</a:t>
             </a:r>
           </a:p>
         </p:txBody>
@@ -2255,6 +2261,81 @@
 </p:notes>
 </file>
 
+<file path=ppt/notesSlides/notesSlide30.xml><?xml version="1.0" encoding="utf-8"?>
+<p:notes xmlns:a="http://schemas.openxmlformats.org/drawingml/2006/main" xmlns:p="http://schemas.openxmlformats.org/presentationml/2006/main" xmlns:r="http://schemas.openxmlformats.org/officeDocument/2006/relationships">
+  <p:cSld>
+    <p:spTree>
+      <p:nvGrpSpPr>
+        <p:cNvPr id="1" name=""/>
+        <p:cNvGrpSpPr/>
+        <p:nvPr/>
+      </p:nvGrpSpPr>
+      <p:grpSpPr>
+        <a:xfrm>
+          <a:off x="0" y="0"/>
+          <a:ext cx="0" cy="0"/>
+          <a:chOff x="0" y="0"/>
+          <a:chExt cx="0" cy="0"/>
+        </a:xfrm>
+      </p:grpSpPr>
+      <p:sp>
+        <p:nvSpPr>
+          <p:cNvPr id="2" name="Slide Image Placeholder 1"/>
+          <p:cNvSpPr>
+            <a:spLocks noGrp="1"/>
+          </p:cNvSpPr>
+          <p:nvPr>
+            <p:ph type="sldImg" idx="2"/>
+          </p:nvPr>
+        </p:nvSpPr>
+        <p:spPr/>
+      </p:sp>
+      <p:sp>
+        <p:nvSpPr>
+          <p:cNvPr id="3" name="Notes Placeholder 2"/>
+          <p:cNvSpPr>
+            <a:spLocks noGrp="1"/>
+          </p:cNvSpPr>
+          <p:nvPr>
+            <p:ph type="body" idx="3" sz="quarter"/>
+          </p:nvPr>
+        </p:nvSpPr>
+        <p:spPr/>
+        <p:txBody>
+          <a:bodyPr/>
+          <a:lstStyle/>
+          <a:p>
+            <a:r>
+              <a:t>LIVE, 1 minute. Read it and leave it open: today's flag becomes a column of tomorrow's table. The</a:t>
+            </a:r>
+          </a:p>
+          <a:p>
+            <a:r>
+              <a:t>pre-read for Thursday ships tonight. Then the tentative IITGN block.</a:t>
+            </a:r>
+          </a:p>
+        </p:txBody>
+      </p:sp>
+      <p:sp>
+        <p:nvSpPr>
+          <p:cNvPr id="4" name="Slide Number Placeholder 3"/>
+          <p:cNvSpPr>
+            <a:spLocks noGrp="1"/>
+          </p:cNvSpPr>
+          <p:nvPr>
+            <p:ph type="sldNum" idx="5" sz="quarter"/>
+          </p:nvPr>
+        </p:nvSpPr>
+        <p:spPr/>
+      </p:sp>
+    </p:spTree>
+  </p:cSld>
+  <p:clrMapOvr>
+    <a:masterClrMapping/>
+  </p:clrMapOvr>
+</p:notes>
+</file>
+
 <file path=ppt/notesSlides/notesSlide4.xml><?xml version="1.0" encoding="utf-8"?>
 <p:notes xmlns:a="http://schemas.openxmlformats.org/drawingml/2006/main" xmlns:p="http://schemas.openxmlformats.org/presentationml/2006/main" xmlns:r="http://schemas.openxmlformats.org/officeDocument/2006/relationships">
   <p:cSld>
@@ -2620,7 +2701,7 @@
           <a:lstStyle/>
           <a:p>
             <a:r>
-              <a:t>LIVE, 1 minute. Two readings of "the month before": the calendar's, and the row LAG reads. They</a:t>
+              <a:t>LIVE, 1 minute. "The month before" has two readings: the calendar's, and the row LAG reads. They</a:t>
             </a:r>
           </a:p>
           <a:p>
@@ -5983,7 +6064,7 @@
                 </a:solidFill>
                 <a:latin typeface="Georgia"/>
               </a:rPr>
-              <a:t>“Before we ring anyone: one of your flagged members rang our help line to say he was travelling in August and has not stopped buying. Is your flag wrong about him, and how many others?”</a:t>
+              <a:t>“Before we ring anyone: one of your flagged members rang our help line to say they were travelling in August and have not stopped buying. Is your flag wrong about them, and how many others?”</a:t>
             </a:r>
           </a:p>
         </p:txBody>
@@ -6298,7 +6379,7 @@
                 </a:solidFill>
                 <a:latin typeface="Calibri"/>
               </a:rPr>
-              <a:t>1 / 29</a:t>
+              <a:t>1 / 30</a:t>
             </a:r>
           </a:p>
         </p:txBody>
@@ -7246,7 +7327,7 @@
                 </a:solidFill>
                 <a:latin typeface="Calibri"/>
               </a:rPr>
-              <a:t>S8  ·  10 / 29</a:t>
+              <a:t>S8  ·  10 / 30</a:t>
             </a:r>
           </a:p>
         </p:txBody>
@@ -7487,7 +7568,7 @@
                 </a:solidFill>
                 <a:latin typeface="Calibri"/>
               </a:rPr>
-              <a:t>What did LAG compare for the member who says he was on holiday?</a:t>
+              <a:t>What did LAG compare for the member who says they were on holiday?</a:t>
             </a:r>
           </a:p>
         </p:txBody>
@@ -7844,7 +7925,7 @@
         <p:spPr>
           <a:xfrm>
             <a:off x="530352" y="2883408"/>
-            <a:ext cx="11130991" cy="807720"/>
+            <a:ext cx="11130991" cy="1074420"/>
           </a:xfrm>
           <a:prstGeom prst="roundRect">
             <a:avLst>
@@ -7892,7 +7973,7 @@
         <p:spPr>
           <a:xfrm>
             <a:off x="676656" y="3011424"/>
-            <a:ext cx="45720" cy="551688"/>
+            <a:ext cx="45720" cy="818388"/>
           </a:xfrm>
           <a:prstGeom prst="roundRect">
             <a:avLst>
@@ -7938,7 +8019,7 @@
         <p:spPr>
           <a:xfrm>
             <a:off x="877824" y="3002280"/>
-            <a:ext cx="10564063" cy="624840"/>
+            <a:ext cx="10564063" cy="891540"/>
           </a:xfrm>
           <a:prstGeom prst="rect">
             <a:avLst/>
@@ -7967,7 +8048,7 @@
                 </a:solidFill>
                 <a:latin typeface="Calibri"/>
               </a:rPr>
-              <a:t>C-0216 of Retail-Plus stands at place 23 on his segment's list. Which month did LAG treat as "last month" for his September, as a letter? a) August; b) July; c) June; d) none, since his August is empty.</a:t>
+              <a:t>C-0216 of Retail-Plus stands at place 23 on the Retail-Plus list. Which month did LAG treat as "last month" for C-0216's September, as a letter? a) August; b) July; c) June; d) none, since their August is empty.</a:t>
             </a:r>
           </a:p>
         </p:txBody>
@@ -8239,7 +8320,7 @@
                 </a:solidFill>
                 <a:latin typeface="Calibri"/>
               </a:rPr>
-              <a:t>S9  ·  11 / 29</a:t>
+              <a:t>S9  ·  11 / 30</a:t>
             </a:r>
           </a:p>
         </p:txBody>
@@ -8480,14 +8561,14 @@
                 </a:solidFill>
                 <a:latin typeface="Calibri"/>
               </a:rPr>
-              <a:t>What did LAG compare for the member who says he was on holiday?</a:t>
+              <a:t>What did LAG compare for the member who says they were on holiday?</a:t>
             </a:r>
           </a:p>
         </p:txBody>
       </p:sp>
       <p:pic>
         <p:nvPicPr>
-          <p:cNvPr id="9" name="mermaid diagram" descr="d7920b8c8aeac347.png"/>
+          <p:cNvPr id="9" name="mermaid diagram" descr="cae16322f66e6210.png"/>
           <p:cNvPicPr>
             <a:picLocks noChangeAspect="1"/>
           </p:cNvPicPr>
@@ -8501,8 +8582,8 @@
         </p:blipFill>
         <p:spPr>
           <a:xfrm>
-            <a:off x="1409547" y="1956816"/>
-            <a:ext cx="9372600" cy="2000250"/>
+            <a:off x="3352647" y="1956816"/>
+            <a:ext cx="5486400" cy="1557337"/>
           </a:xfrm>
           <a:prstGeom prst="rect">
             <a:avLst/>
@@ -8517,7 +8598,7 @@
         </p:nvSpPr>
         <p:spPr>
           <a:xfrm>
-            <a:off x="530352" y="4103370"/>
+            <a:off x="530352" y="3660457"/>
             <a:ext cx="11130991" cy="807720"/>
           </a:xfrm>
           <a:prstGeom prst="roundRect">
@@ -8565,7 +8646,7 @@
         </p:nvSpPr>
         <p:spPr>
           <a:xfrm>
-            <a:off x="676656" y="4231385"/>
+            <a:off x="676656" y="3788473"/>
             <a:ext cx="45720" cy="551688"/>
           </a:xfrm>
           <a:prstGeom prst="roundRect">
@@ -8611,7 +8692,7 @@
         </p:nvSpPr>
         <p:spPr>
           <a:xfrm>
-            <a:off x="877824" y="4222242"/>
+            <a:off x="877824" y="3779329"/>
             <a:ext cx="10564063" cy="624840"/>
           </a:xfrm>
           <a:prstGeom prst="rect">
@@ -8641,7 +8722,7 @@
                 </a:solidFill>
                 <a:latin typeface="Calibri"/>
               </a:rPr>
-              <a:t>There is no August row, so LAG compared September with July and July with May. Chapter 4's flag called that two months of falls; his rows say August is simply empty.</a:t>
+              <a:t>There is no August row, so LAG compared September with July and July with May. Chapter 4's flag called that two months of falls; C-0216's rows say August is simply empty.</a:t>
             </a:r>
           </a:p>
         </p:txBody>
@@ -8913,7 +8994,7 @@
                 </a:solidFill>
                 <a:latin typeface="Calibri"/>
               </a:rPr>
-              <a:t>S10  ·  12 / 29</a:t>
+              <a:t>S10  ·  12 / 30</a:t>
             </a:r>
           </a:p>
         </p:txBody>
@@ -9643,7 +9724,7 @@
                 </a:solidFill>
                 <a:latin typeface="Calibri"/>
               </a:rPr>
-              <a:t>The hurried reply to the head of Retail-Plus is that C-0216 did spend less each time he ordered, and every one of the sixteen gets the same call.</a:t>
+              <a:t>The hurried reply to the head of Retail-Plus is that C-0216 did spend less with each order, and every one of the sixteen gets the same call.</a:t>
             </a:r>
           </a:p>
         </p:txBody>
@@ -9915,7 +9996,7 @@
                 </a:solidFill>
                 <a:latin typeface="Calibri"/>
               </a:rPr>
-              <a:t>S11  ·  13 / 29</a:t>
+              <a:t>S11  ·  13 / 30</a:t>
             </a:r>
           </a:p>
         </p:txBody>
@@ -10163,7 +10244,7 @@
       </p:sp>
       <p:pic>
         <p:nvPicPr>
-          <p:cNvPr id="9" name="mermaid diagram" descr="6eea9dc41337f1ff.png"/>
+          <p:cNvPr id="9" name="mermaid diagram" descr="c8994adb0d915e8d.png"/>
           <p:cNvPicPr>
             <a:picLocks noChangeAspect="1"/>
           </p:cNvPicPr>
@@ -10177,8 +10258,8 @@
         </p:blipFill>
         <p:spPr>
           <a:xfrm>
-            <a:off x="1866747" y="1956816"/>
-            <a:ext cx="8458200" cy="2771775"/>
+            <a:off x="1909610" y="1956816"/>
+            <a:ext cx="8372475" cy="1800225"/>
           </a:xfrm>
           <a:prstGeom prst="rect">
             <a:avLst/>
@@ -10193,7 +10274,7 @@
         </p:nvSpPr>
         <p:spPr>
           <a:xfrm>
-            <a:off x="530352" y="4874895"/>
+            <a:off x="530352" y="3903345"/>
             <a:ext cx="11130991" cy="807720"/>
           </a:xfrm>
           <a:prstGeom prst="roundRect">
@@ -10241,7 +10322,7 @@
         </p:nvSpPr>
         <p:spPr>
           <a:xfrm>
-            <a:off x="676656" y="5002911"/>
+            <a:off x="676656" y="4031360"/>
             <a:ext cx="45720" cy="551688"/>
           </a:xfrm>
           <a:prstGeom prst="roundRect">
@@ -10287,7 +10368,7 @@
         </p:nvSpPr>
         <p:spPr>
           <a:xfrm>
-            <a:off x="877824" y="4993767"/>
+            <a:off x="877824" y="4022217"/>
             <a:ext cx="10564063" cy="624840"/>
           </a:xfrm>
           <a:prstGeom prst="rect">
@@ -10589,7 +10670,7 @@
                 </a:solidFill>
                 <a:latin typeface="Calibri"/>
               </a:rPr>
-              <a:t>S12  ·  14 / 29</a:t>
+              <a:t>S12  ·  14 / 30</a:t>
             </a:r>
           </a:p>
         </p:txBody>
@@ -11504,7 +11585,7 @@
                 </a:solidFill>
                 <a:latin typeface="Calibri"/>
               </a:rPr>
-              <a:t>Every call that goes out now describes three consecutive months that each fell, months the member can check on his own statement.</a:t>
+              <a:t>Every call that goes out now describes three consecutive months that each fell, months the member can check on their own statement.</a:t>
             </a:r>
           </a:p>
         </p:txBody>
@@ -11776,7 +11857,7 @@
                 </a:solidFill>
                 <a:latin typeface="Calibri"/>
               </a:rPr>
-              <a:t>S13  ·  15 / 29</a:t>
+              <a:t>S13  ·  15 / 30</a:t>
             </a:r>
           </a:p>
         </p:txBody>
@@ -12725,7 +12806,7 @@
                 </a:solidFill>
                 <a:latin typeface="Calibri"/>
               </a:rPr>
-              <a:t>S14  ·  16 / 29</a:t>
+              <a:t>S14  ·  16 / 30</a:t>
             </a:r>
           </a:p>
         </p:txBody>
@@ -13643,7 +13724,7 @@
                 </a:solidFill>
                 <a:latin typeface="Calibri"/>
               </a:rPr>
-              <a:t>S15  ·  17 / 29</a:t>
+              <a:t>S15  ·  17 / 30</a:t>
             </a:r>
           </a:p>
         </p:txBody>
@@ -14614,7 +14695,7 @@
                 </a:solidFill>
                 <a:latin typeface="Calibri"/>
               </a:rPr>
-              <a:t>[D] A member says he was on holiday and should not be flagged: how does your definition treat a month with no orders, and why not fill it with zero?</a:t>
+              <a:t>[D] A member says they were on holiday and should not be flagged: how does your definition treat a month with no orders, and why not fill it with zero?</a:t>
             </a:r>
           </a:p>
         </p:txBody>
@@ -14886,7 +14967,7 @@
                 </a:solidFill>
                 <a:latin typeface="Calibri"/>
               </a:rPr>
-              <a:t>S16  ·  18 / 29</a:t>
+              <a:t>S16  ·  18 / 30</a:t>
             </a:r>
           </a:p>
         </p:txBody>
@@ -15397,7 +15478,7 @@
                 </a:solidFill>
                 <a:latin typeface="Calibri"/>
               </a:rPr>
-              <a:t>19 / 29</a:t>
+              <a:t>19 / 30</a:t>
             </a:r>
           </a:p>
         </p:txBody>
@@ -16212,7 +16293,7 @@
                 </a:solidFill>
                 <a:latin typeface="Calibri"/>
               </a:rPr>
-              <a:t>S1  ·  2 / 29</a:t>
+              <a:t>S1  ·  2 / 30</a:t>
             </a:r>
           </a:p>
         </p:txBody>
@@ -17987,7 +18068,7 @@
                 </a:solidFill>
                 <a:latin typeface="Calibri"/>
               </a:rPr>
-              <a:t>S17  ·  20 / 29</a:t>
+              <a:t>S17  ·  20 / 30</a:t>
             </a:r>
           </a:p>
         </p:txBody>
@@ -19187,7 +19268,7 @@
                 </a:solidFill>
                 <a:latin typeface="Calibri"/>
               </a:rPr>
-              <a:t>S18  ·  21 / 29</a:t>
+              <a:t>S18  ·  21 / 30</a:t>
             </a:r>
           </a:p>
         </p:txBody>
@@ -19698,7 +19779,7 @@
                 </a:solidFill>
                 <a:latin typeface="Calibri"/>
               </a:rPr>
-              <a:t>22 / 29</a:t>
+              <a:t>22 / 30</a:t>
             </a:r>
           </a:p>
         </p:txBody>
@@ -20568,7 +20649,7 @@
                 </a:solidFill>
                 <a:latin typeface="Calibri"/>
               </a:rPr>
-              <a:t>S19  ·  23 / 29</a:t>
+              <a:t>S19  ·  23 / 30</a:t>
             </a:r>
           </a:p>
         </p:txBody>
@@ -20816,7 +20897,7 @@
       </p:sp>
       <p:pic>
         <p:nvPicPr>
-          <p:cNvPr id="9" name="mermaid diagram" descr="a69f3fbfe7bc78a4.png"/>
+          <p:cNvPr id="9" name="mermaid diagram" descr="11811dd0a6b07bd4.png"/>
           <p:cNvPicPr>
             <a:picLocks noChangeAspect="1"/>
           </p:cNvPicPr>
@@ -20831,7 +20912,7 @@
         <p:spPr>
           <a:xfrm>
             <a:off x="530352" y="1956816"/>
-            <a:ext cx="11130991" cy="1105204"/>
+            <a:ext cx="11130991" cy="822589"/>
           </a:xfrm>
           <a:prstGeom prst="rect">
             <a:avLst/>
@@ -20846,7 +20927,7 @@
         </p:nvSpPr>
         <p:spPr>
           <a:xfrm>
-            <a:off x="530352" y="3171748"/>
+            <a:off x="530352" y="2889133"/>
             <a:ext cx="502920" cy="333756"/>
           </a:xfrm>
           <a:prstGeom prst="rect">
@@ -20881,7 +20962,7 @@
         </p:nvSpPr>
         <p:spPr>
           <a:xfrm>
-            <a:off x="1097280" y="3208324"/>
+            <a:off x="1097280" y="2925709"/>
             <a:ext cx="10564063" cy="368808"/>
           </a:xfrm>
           <a:prstGeom prst="rect">
@@ -20915,7 +20996,7 @@
         </p:nvSpPr>
         <p:spPr>
           <a:xfrm>
-            <a:off x="530352" y="3613708"/>
+            <a:off x="530352" y="3331093"/>
             <a:ext cx="502920" cy="333756"/>
           </a:xfrm>
           <a:prstGeom prst="rect">
@@ -20950,7 +21031,7 @@
         </p:nvSpPr>
         <p:spPr>
           <a:xfrm>
-            <a:off x="1097280" y="3650284"/>
+            <a:off x="1097280" y="3367669"/>
             <a:ext cx="10564063" cy="368808"/>
           </a:xfrm>
           <a:prstGeom prst="rect">
@@ -20984,7 +21065,7 @@
         </p:nvSpPr>
         <p:spPr>
           <a:xfrm>
-            <a:off x="530352" y="4055668"/>
+            <a:off x="530352" y="3773053"/>
             <a:ext cx="502920" cy="333756"/>
           </a:xfrm>
           <a:prstGeom prst="rect">
@@ -21019,7 +21100,7 @@
         </p:nvSpPr>
         <p:spPr>
           <a:xfrm>
-            <a:off x="1097280" y="4092244"/>
+            <a:off x="1097280" y="3809629"/>
             <a:ext cx="10564063" cy="368808"/>
           </a:xfrm>
           <a:prstGeom prst="rect">
@@ -21053,7 +21134,7 @@
         </p:nvSpPr>
         <p:spPr>
           <a:xfrm>
-            <a:off x="530352" y="4497628"/>
+            <a:off x="530352" y="4215013"/>
             <a:ext cx="502920" cy="333756"/>
           </a:xfrm>
           <a:prstGeom prst="rect">
@@ -21088,7 +21169,7 @@
         </p:nvSpPr>
         <p:spPr>
           <a:xfrm>
-            <a:off x="1097280" y="4534204"/>
+            <a:off x="1097280" y="4251589"/>
             <a:ext cx="10564063" cy="368808"/>
           </a:xfrm>
           <a:prstGeom prst="rect">
@@ -21122,7 +21203,7 @@
         </p:nvSpPr>
         <p:spPr>
           <a:xfrm>
-            <a:off x="530352" y="4939588"/>
+            <a:off x="530352" y="4656973"/>
             <a:ext cx="502920" cy="333756"/>
           </a:xfrm>
           <a:prstGeom prst="rect">
@@ -21157,7 +21238,7 @@
         </p:nvSpPr>
         <p:spPr>
           <a:xfrm>
-            <a:off x="1097280" y="4976164"/>
+            <a:off x="1097280" y="4693549"/>
             <a:ext cx="10564063" cy="368808"/>
           </a:xfrm>
           <a:prstGeom prst="rect">
@@ -21191,7 +21272,7 @@
         </p:nvSpPr>
         <p:spPr>
           <a:xfrm>
-            <a:off x="530352" y="5381548"/>
+            <a:off x="530352" y="5098933"/>
             <a:ext cx="502920" cy="333756"/>
           </a:xfrm>
           <a:prstGeom prst="rect">
@@ -21226,7 +21307,7 @@
         </p:nvSpPr>
         <p:spPr>
           <a:xfrm>
-            <a:off x="1097280" y="5418124"/>
+            <a:off x="1097280" y="5135509"/>
             <a:ext cx="10564063" cy="368808"/>
           </a:xfrm>
           <a:prstGeom prst="rect">
@@ -21519,7 +21600,7 @@
                 </a:solidFill>
                 <a:latin typeface="Calibri"/>
               </a:rPr>
-              <a:t>S20  ·  24 / 29</a:t>
+              <a:t>S20  ·  24 / 30</a:t>
             </a:r>
           </a:p>
         </p:txBody>
@@ -22472,7 +22553,7 @@
                 </a:solidFill>
                 <a:latin typeface="Calibri"/>
               </a:rPr>
-              <a:t>S21  ·  25 / 29</a:t>
+              <a:t>S21  ·  25 / 30</a:t>
             </a:r>
           </a:p>
         </p:txBody>
@@ -22678,7 +22759,7 @@
                 </a:solidFill>
                 <a:latin typeface="Georgia"/>
               </a:rPr>
-              <a:t>The interview drill, for the lab: twelve questions</a:t>
+              <a:t>The interview drill, for the lab: ten questions</a:t>
             </a:r>
           </a:p>
         </p:txBody>
@@ -22768,7 +22849,7 @@
                 </a:solidFill>
                 <a:latin typeface="Calibri"/>
               </a:rPr>
-              <a:t>Which interview questions does today equip you to answer, and how are they tagged?</a:t>
+              <a:t>Which staple and frequent interview questions does today equip you to answer?</a:t>
             </a:r>
           </a:p>
         </p:txBody>
@@ -22782,8 +22863,8 @@
           <p:nvPr/>
         </p:nvGraphicFramePr>
         <p:xfrm>
-          <a:off x="530352" y="1874012"/>
-          <a:ext cx="11130991" cy="4134104"/>
+          <a:off x="530352" y="1907032"/>
+          <a:ext cx="11130991" cy="4068064"/>
         </p:xfrm>
         <a:graphic>
           <a:graphicData uri="http://schemas.openxmlformats.org/drawingml/2006/table">
@@ -22795,14 +22876,14 @@
                 <a:gridCol w="914400"/>
                 <a:gridCol w="10216591"/>
               </a:tblGrid>
-              <a:tr h="318008">
+              <a:tr h="369824">
                 <a:tc>
                   <a:txBody>
                     <a:bodyPr/>
                     <a:lstStyle/>
                     <a:p>
                       <a:r>
-                        <a:rPr sz="1150" b="1" i="0">
+                        <a:rPr sz="1450" b="1" i="0">
                           <a:solidFill>
                             <a:srgbClr val="FFFFFF"/>
                           </a:solidFill>
@@ -22824,7 +22905,7 @@
                     <a:lstStyle/>
                     <a:p>
                       <a:r>
-                        <a:rPr sz="1150" b="1" i="0">
+                        <a:rPr sz="1450" b="1" i="0">
                           <a:solidFill>
                             <a:srgbClr val="FFFFFF"/>
                           </a:solidFill>
@@ -22841,14 +22922,14 @@
                   </a:tcPr>
                 </a:tc>
               </a:tr>
-              <a:tr h="318008">
+              <a:tr h="369824">
                 <a:tc>
                   <a:txBody>
                     <a:bodyPr/>
                     <a:lstStyle/>
                     <a:p>
                       <a:r>
-                        <a:rPr sz="1100" b="0" i="0">
+                        <a:rPr sz="1400" b="0" i="0">
                           <a:solidFill>
                             <a:srgbClr val="1A1440"/>
                           </a:solidFill>
@@ -22870,7 +22951,7 @@
                     <a:lstStyle/>
                     <a:p>
                       <a:r>
-                        <a:rPr sz="1100" b="0" i="0">
+                        <a:rPr sz="1400" b="0" i="0">
                           <a:solidFill>
                             <a:srgbClr val="1A1440"/>
                           </a:solidFill>
@@ -22887,14 +22968,14 @@
                   </a:tcPr>
                 </a:tc>
               </a:tr>
-              <a:tr h="318008">
+              <a:tr h="369824">
                 <a:tc>
                   <a:txBody>
                     <a:bodyPr/>
                     <a:lstStyle/>
                     <a:p>
                       <a:r>
-                        <a:rPr sz="1100" b="0" i="0">
+                        <a:rPr sz="1400" b="0" i="0">
                           <a:solidFill>
                             <a:srgbClr val="1A1440"/>
                           </a:solidFill>
@@ -22916,7 +22997,7 @@
                     <a:lstStyle/>
                     <a:p>
                       <a:r>
-                        <a:rPr sz="1100" b="0" i="0">
+                        <a:rPr sz="1400" b="0" i="0">
                           <a:solidFill>
                             <a:srgbClr val="1A1440"/>
                           </a:solidFill>
@@ -22933,14 +23014,14 @@
                   </a:tcPr>
                 </a:tc>
               </a:tr>
-              <a:tr h="318008">
+              <a:tr h="369824">
                 <a:tc>
                   <a:txBody>
                     <a:bodyPr/>
                     <a:lstStyle/>
                     <a:p>
                       <a:r>
-                        <a:rPr sz="1100" b="0" i="0">
+                        <a:rPr sz="1400" b="0" i="0">
                           <a:solidFill>
                             <a:srgbClr val="1A1440"/>
                           </a:solidFill>
@@ -22962,7 +23043,7 @@
                     <a:lstStyle/>
                     <a:p>
                       <a:r>
-                        <a:rPr sz="1100" b="0" i="0">
+                        <a:rPr sz="1400" b="0" i="0">
                           <a:solidFill>
                             <a:srgbClr val="1A1440"/>
                           </a:solidFill>
@@ -22979,14 +23060,14 @@
                   </a:tcPr>
                 </a:tc>
               </a:tr>
-              <a:tr h="318008">
+              <a:tr h="369824">
                 <a:tc>
                   <a:txBody>
                     <a:bodyPr/>
                     <a:lstStyle/>
                     <a:p>
                       <a:r>
-                        <a:rPr sz="1100" b="0" i="0">
+                        <a:rPr sz="1400" b="0" i="0">
                           <a:solidFill>
                             <a:srgbClr val="1A1440"/>
                           </a:solidFill>
@@ -23008,7 +23089,7 @@
                     <a:lstStyle/>
                     <a:p>
                       <a:r>
-                        <a:rPr sz="1100" b="0" i="0">
+                        <a:rPr sz="1400" b="0" i="0">
                           <a:solidFill>
                             <a:srgbClr val="1A1440"/>
                           </a:solidFill>
@@ -23025,14 +23106,14 @@
                   </a:tcPr>
                 </a:tc>
               </a:tr>
-              <a:tr h="318008">
+              <a:tr h="369824">
                 <a:tc>
                   <a:txBody>
                     <a:bodyPr/>
                     <a:lstStyle/>
                     <a:p>
                       <a:r>
-                        <a:rPr sz="1100" b="0" i="0">
+                        <a:rPr sz="1400" b="0" i="0">
                           <a:solidFill>
                             <a:srgbClr val="1A1440"/>
                           </a:solidFill>
@@ -23054,7 +23135,7 @@
                     <a:lstStyle/>
                     <a:p>
                       <a:r>
-                        <a:rPr sz="1100" b="0" i="0">
+                        <a:rPr sz="1400" b="0" i="0">
                           <a:solidFill>
                             <a:srgbClr val="1A1440"/>
                           </a:solidFill>
@@ -23071,14 +23152,14 @@
                   </a:tcPr>
                 </a:tc>
               </a:tr>
-              <a:tr h="318008">
+              <a:tr h="369824">
                 <a:tc>
                   <a:txBody>
                     <a:bodyPr/>
                     <a:lstStyle/>
                     <a:p>
                       <a:r>
-                        <a:rPr sz="1100" b="0" i="0">
+                        <a:rPr sz="1400" b="0" i="0">
                           <a:solidFill>
                             <a:srgbClr val="1A1440"/>
                           </a:solidFill>
@@ -23100,7 +23181,7 @@
                     <a:lstStyle/>
                     <a:p>
                       <a:r>
-                        <a:rPr sz="1100" b="0" i="0">
+                        <a:rPr sz="1400" b="0" i="0">
                           <a:solidFill>
                             <a:srgbClr val="1A1440"/>
                           </a:solidFill>
@@ -23117,14 +23198,14 @@
                   </a:tcPr>
                 </a:tc>
               </a:tr>
-              <a:tr h="318008">
+              <a:tr h="369824">
                 <a:tc>
                   <a:txBody>
                     <a:bodyPr/>
                     <a:lstStyle/>
                     <a:p>
                       <a:r>
-                        <a:rPr sz="1100" b="0" i="0">
+                        <a:rPr sz="1400" b="0" i="0">
                           <a:solidFill>
                             <a:srgbClr val="1A1440"/>
                           </a:solidFill>
@@ -23146,7 +23227,7 @@
                     <a:lstStyle/>
                     <a:p>
                       <a:r>
-                        <a:rPr sz="1100" b="0" i="0">
+                        <a:rPr sz="1400" b="0" i="0">
                           <a:solidFill>
                             <a:srgbClr val="1A1440"/>
                           </a:solidFill>
@@ -23163,14 +23244,14 @@
                   </a:tcPr>
                 </a:tc>
               </a:tr>
-              <a:tr h="318008">
+              <a:tr h="369824">
                 <a:tc>
                   <a:txBody>
                     <a:bodyPr/>
                     <a:lstStyle/>
                     <a:p>
                       <a:r>
-                        <a:rPr sz="1100" b="0" i="0">
+                        <a:rPr sz="1400" b="0" i="0">
                           <a:solidFill>
                             <a:srgbClr val="1A1440"/>
                           </a:solidFill>
@@ -23192,7 +23273,7 @@
                     <a:lstStyle/>
                     <a:p>
                       <a:r>
-                        <a:rPr sz="1100" b="0" i="0">
+                        <a:rPr sz="1400" b="0" i="0">
                           <a:solidFill>
                             <a:srgbClr val="1A1440"/>
                           </a:solidFill>
@@ -23209,14 +23290,14 @@
                   </a:tcPr>
                 </a:tc>
               </a:tr>
-              <a:tr h="318008">
+              <a:tr h="369824">
                 <a:tc>
                   <a:txBody>
                     <a:bodyPr/>
                     <a:lstStyle/>
                     <a:p>
                       <a:r>
-                        <a:rPr sz="1100" b="0" i="0">
+                        <a:rPr sz="1400" b="0" i="0">
                           <a:solidFill>
                             <a:srgbClr val="1A1440"/>
                           </a:solidFill>
@@ -23238,7 +23319,7 @@
                     <a:lstStyle/>
                     <a:p>
                       <a:r>
-                        <a:rPr sz="1100" b="0" i="0">
+                        <a:rPr sz="1400" b="0" i="0">
                           <a:solidFill>
                             <a:srgbClr val="1A1440"/>
                           </a:solidFill>
@@ -23255,14 +23336,14 @@
                   </a:tcPr>
                 </a:tc>
               </a:tr>
-              <a:tr h="318008">
+              <a:tr h="369824">
                 <a:tc>
                   <a:txBody>
                     <a:bodyPr/>
                     <a:lstStyle/>
                     <a:p>
                       <a:r>
-                        <a:rPr sz="1100" b="0" i="0">
+                        <a:rPr sz="1400" b="0" i="0">
                           <a:solidFill>
                             <a:srgbClr val="1A1440"/>
                           </a:solidFill>
@@ -23284,7 +23365,7 @@
                     <a:lstStyle/>
                     <a:p>
                       <a:r>
-                        <a:rPr sz="1100" b="0" i="0">
+                        <a:rPr sz="1400" b="0" i="0">
                           <a:solidFill>
                             <a:srgbClr val="1A1440"/>
                           </a:solidFill>
@@ -23301,98 +23382,6 @@
                   </a:tcPr>
                 </a:tc>
               </a:tr>
-              <a:tr h="318008">
-                <a:tc>
-                  <a:txBody>
-                    <a:bodyPr/>
-                    <a:lstStyle/>
-                    <a:p>
-                      <a:r>
-                        <a:rPr sz="1100" b="0" i="0">
-                          <a:solidFill>
-                            <a:srgbClr val="1A1440"/>
-                          </a:solidFill>
-                          <a:latin typeface="Calibri"/>
-                        </a:rPr>
-                        <a:t>[D]</a:t>
-                      </a:r>
-                    </a:p>
-                  </a:txBody>
-                  <a:tcPr marL="101600" marR="101600" marT="38100" marB="38100" anchor="ctr">
-                    <a:solidFill>
-                      <a:srgbClr val="FFFFFF"/>
-                    </a:solidFill>
-                  </a:tcPr>
-                </a:tc>
-                <a:tc>
-                  <a:txBody>
-                    <a:bodyPr/>
-                    <a:lstStyle/>
-                    <a:p>
-                      <a:r>
-                        <a:rPr sz="1100" b="0" i="0">
-                          <a:solidFill>
-                            <a:srgbClr val="1A1440"/>
-                          </a:solidFill>
-                          <a:latin typeface="Calibri"/>
-                        </a:rPr>
-                        <a:t>The business says ties rank the same: which function, and how many rows might the top-N report ship?</a:t>
-                      </a:r>
-                    </a:p>
-                  </a:txBody>
-                  <a:tcPr marL="101600" marR="101600" marT="38100" marB="38100" anchor="ctr">
-                    <a:solidFill>
-                      <a:srgbClr val="FFFFFF"/>
-                    </a:solidFill>
-                  </a:tcPr>
-                </a:tc>
-              </a:tr>
-              <a:tr h="318008">
-                <a:tc>
-                  <a:txBody>
-                    <a:bodyPr/>
-                    <a:lstStyle/>
-                    <a:p>
-                      <a:r>
-                        <a:rPr sz="1100" b="0" i="0">
-                          <a:solidFill>
-                            <a:srgbClr val="1A1440"/>
-                          </a:solidFill>
-                          <a:latin typeface="Calibri"/>
-                        </a:rPr>
-                        <a:t>[D]</a:t>
-                      </a:r>
-                    </a:p>
-                  </a:txBody>
-                  <a:tcPr marL="101600" marR="101600" marT="38100" marB="38100" anchor="ctr">
-                    <a:solidFill>
-                      <a:srgbClr val="F4F2FA"/>
-                    </a:solidFill>
-                  </a:tcPr>
-                </a:tc>
-                <a:tc>
-                  <a:txBody>
-                    <a:bodyPr/>
-                    <a:lstStyle/>
-                    <a:p>
-                      <a:r>
-                        <a:rPr sz="1100" b="0" i="0">
-                          <a:solidFill>
-                            <a:srgbClr val="1A1440"/>
-                          </a:solidFill>
-                          <a:latin typeface="Calibri"/>
-                        </a:rPr>
-                        <a:t>A member was on holiday: how does your flag treat a month with no orders, and why not zero?</a:t>
-                      </a:r>
-                    </a:p>
-                  </a:txBody>
-                  <a:tcPr marL="101600" marR="101600" marT="38100" marB="38100" anchor="ctr">
-                    <a:solidFill>
-                      <a:srgbClr val="F4F2FA"/>
-                    </a:solidFill>
-                  </a:tcPr>
-                </a:tc>
-              </a:tr>
             </a:tbl>
           </a:graphicData>
         </a:graphic>
@@ -23664,7 +23653,7 @@
                 </a:solidFill>
                 <a:latin typeface="Calibri"/>
               </a:rPr>
-              <a:t>D22  ·  26 / 29</a:t>
+              <a:t>D22  ·  26 / 30</a:t>
             </a:r>
           </a:p>
         </p:txBody>
@@ -23870,6 +23859,839 @@
                 </a:solidFill>
                 <a:latin typeface="Georgia"/>
               </a:rPr>
+              <a:t>The interview drill, for the lab: three to finish</a:t>
+            </a:r>
+          </a:p>
+        </p:txBody>
+      </p:sp>
+      <p:sp>
+        <p:nvSpPr>
+          <p:cNvPr id="8" name="Rounded Rectangle 7"/>
+          <p:cNvSpPr/>
+          <p:nvPr/>
+        </p:nvSpPr>
+        <p:spPr>
+          <a:xfrm>
+            <a:off x="10701223" y="822960"/>
+            <a:ext cx="960120" cy="256032"/>
+          </a:xfrm>
+          <a:prstGeom prst="roundRect">
+            <a:avLst>
+              <a:gd name="adj" fmla="val 50000"/>
+            </a:avLst>
+          </a:prstGeom>
+          <a:solidFill>
+            <a:srgbClr val="1A0F5C"/>
+          </a:solidFill>
+          <a:ln>
+            <a:noFill/>
+          </a:ln>
+          <a:effectLst/>
+        </p:spPr>
+        <p:style>
+          <a:lnRef idx="1">
+            <a:schemeClr val="accent1"/>
+          </a:lnRef>
+          <a:fillRef idx="3">
+            <a:schemeClr val="accent1"/>
+          </a:fillRef>
+          <a:effectRef idx="2">
+            <a:schemeClr val="accent1"/>
+          </a:effectRef>
+          <a:fontRef idx="minor">
+            <a:schemeClr val="lt1"/>
+          </a:fontRef>
+        </p:style>
+        <p:txBody>
+          <a:bodyPr rtlCol="0" anchor="ctr" wrap="none" lIns="25400" rIns="25400" tIns="0" bIns="0"/>
+          <a:lstStyle/>
+          <a:p>
+            <a:pPr algn="ctr"/>
+            <a:r>
+              <a:rPr sz="800" b="1" spc="200">
+                <a:solidFill>
+                  <a:srgbClr val="FFFFFF"/>
+                </a:solidFill>
+                <a:latin typeface="Calibri"/>
+              </a:rPr>
+              <a:t>DEPTH</a:t>
+            </a:r>
+          </a:p>
+        </p:txBody>
+      </p:sp>
+      <p:sp>
+        <p:nvSpPr>
+          <p:cNvPr id="9" name="TextBox 8"/>
+          <p:cNvSpPr txBox="1"/>
+          <p:nvPr/>
+        </p:nvSpPr>
+        <p:spPr>
+          <a:xfrm>
+            <a:off x="530352" y="1243584"/>
+            <a:ext cx="11130991" cy="234696"/>
+          </a:xfrm>
+          <a:prstGeom prst="rect">
+            <a:avLst/>
+          </a:prstGeom>
+          <a:noFill/>
+        </p:spPr>
+        <p:txBody>
+          <a:bodyPr wrap="square" anchor="t" lIns="0" rIns="0" tIns="0" bIns="0">
+            <a:spAutoFit/>
+          </a:bodyPr>
+          <a:lstStyle/>
+          <a:p>
+            <a:pPr algn="l"/>
+            <a:r>
+              <a:rPr sz="1200" b="0" i="0">
+                <a:solidFill>
+                  <a:srgbClr val="6B6690"/>
+                </a:solidFill>
+                <a:latin typeface="Calibri"/>
+              </a:rPr>
+              <a:t>Which differentiator questions close the drill?</a:t>
+            </a:r>
+          </a:p>
+        </p:txBody>
+      </p:sp>
+      <p:graphicFrame>
+        <p:nvGraphicFramePr>
+          <p:cNvPr id="10" name="Table 9"/>
+          <p:cNvGraphicFramePr>
+            <a:graphicFrameLocks noGrp="1"/>
+          </p:cNvGraphicFramePr>
+          <p:nvPr/>
+        </p:nvGraphicFramePr>
+        <p:xfrm>
+          <a:off x="530352" y="1956816"/>
+          <a:ext cx="11130991" cy="1479296"/>
+        </p:xfrm>
+        <a:graphic>
+          <a:graphicData uri="http://schemas.openxmlformats.org/drawingml/2006/table">
+            <a:tbl>
+              <a:tblPr firstRow="0" bandRow="0">
+                <a:tableStyleId>{2D5ABB26-0587-4C30-8999-92F81FD0307C}</a:tableStyleId>
+              </a:tblPr>
+              <a:tblGrid>
+                <a:gridCol w="914400"/>
+                <a:gridCol w="10216591"/>
+              </a:tblGrid>
+              <a:tr h="369824">
+                <a:tc>
+                  <a:txBody>
+                    <a:bodyPr/>
+                    <a:lstStyle/>
+                    <a:p>
+                      <a:r>
+                        <a:rPr sz="1450" b="1" i="0">
+                          <a:solidFill>
+                            <a:srgbClr val="FFFFFF"/>
+                          </a:solidFill>
+                          <a:latin typeface="Calibri"/>
+                        </a:rPr>
+                        <a:t>Tag</a:t>
+                      </a:r>
+                    </a:p>
+                  </a:txBody>
+                  <a:tcPr marL="101600" marR="101600" marT="38100" marB="38100" anchor="ctr">
+                    <a:solidFill>
+                      <a:srgbClr val="1A0F5C"/>
+                    </a:solidFill>
+                  </a:tcPr>
+                </a:tc>
+                <a:tc>
+                  <a:txBody>
+                    <a:bodyPr/>
+                    <a:lstStyle/>
+                    <a:p>
+                      <a:r>
+                        <a:rPr sz="1450" b="1" i="0">
+                          <a:solidFill>
+                            <a:srgbClr val="FFFFFF"/>
+                          </a:solidFill>
+                          <a:latin typeface="Calibri"/>
+                        </a:rPr>
+                        <a:t>Question</a:t>
+                      </a:r>
+                    </a:p>
+                  </a:txBody>
+                  <a:tcPr marL="101600" marR="101600" marT="38100" marB="38100" anchor="ctr">
+                    <a:solidFill>
+                      <a:srgbClr val="1A0F5C"/>
+                    </a:solidFill>
+                  </a:tcPr>
+                </a:tc>
+              </a:tr>
+              <a:tr h="369824">
+                <a:tc>
+                  <a:txBody>
+                    <a:bodyPr/>
+                    <a:lstStyle/>
+                    <a:p>
+                      <a:r>
+                        <a:rPr sz="1400" b="0" i="0">
+                          <a:solidFill>
+                            <a:srgbClr val="1A1440"/>
+                          </a:solidFill>
+                          <a:latin typeface="Calibri"/>
+                        </a:rPr>
+                        <a:t>[D]</a:t>
+                      </a:r>
+                    </a:p>
+                  </a:txBody>
+                  <a:tcPr marL="101600" marR="101600" marT="38100" marB="38100" anchor="ctr">
+                    <a:solidFill>
+                      <a:srgbClr val="FFFFFF"/>
+                    </a:solidFill>
+                  </a:tcPr>
+                </a:tc>
+                <a:tc>
+                  <a:txBody>
+                    <a:bodyPr/>
+                    <a:lstStyle/>
+                    <a:p>
+                      <a:r>
+                        <a:rPr sz="1400" b="0" i="0">
+                          <a:solidFill>
+                            <a:srgbClr val="1A1440"/>
+                          </a:solidFill>
+                          <a:latin typeface="Calibri"/>
+                        </a:rPr>
+                        <a:t>The business says ties rank the same: which function, and how many rows might the top-N report ship?</a:t>
+                      </a:r>
+                    </a:p>
+                  </a:txBody>
+                  <a:tcPr marL="101600" marR="101600" marT="38100" marB="38100" anchor="ctr">
+                    <a:solidFill>
+                      <a:srgbClr val="FFFFFF"/>
+                    </a:solidFill>
+                  </a:tcPr>
+                </a:tc>
+              </a:tr>
+              <a:tr h="369824">
+                <a:tc>
+                  <a:txBody>
+                    <a:bodyPr/>
+                    <a:lstStyle/>
+                    <a:p>
+                      <a:r>
+                        <a:rPr sz="1400" b="0" i="0">
+                          <a:solidFill>
+                            <a:srgbClr val="1A1440"/>
+                          </a:solidFill>
+                          <a:latin typeface="Calibri"/>
+                        </a:rPr>
+                        <a:t>[D]</a:t>
+                      </a:r>
+                    </a:p>
+                  </a:txBody>
+                  <a:tcPr marL="101600" marR="101600" marT="38100" marB="38100" anchor="ctr">
+                    <a:solidFill>
+                      <a:srgbClr val="F4F2FA"/>
+                    </a:solidFill>
+                  </a:tcPr>
+                </a:tc>
+                <a:tc>
+                  <a:txBody>
+                    <a:bodyPr/>
+                    <a:lstStyle/>
+                    <a:p>
+                      <a:r>
+                        <a:rPr sz="1400" b="0" i="0">
+                          <a:solidFill>
+                            <a:srgbClr val="1A1440"/>
+                          </a:solidFill>
+                          <a:latin typeface="Calibri"/>
+                        </a:rPr>
+                        <a:t>A member was on holiday: how does your flag treat a month with no orders, and why not zero?</a:t>
+                      </a:r>
+                    </a:p>
+                  </a:txBody>
+                  <a:tcPr marL="101600" marR="101600" marT="38100" marB="38100" anchor="ctr">
+                    <a:solidFill>
+                      <a:srgbClr val="F4F2FA"/>
+                    </a:solidFill>
+                  </a:tcPr>
+                </a:tc>
+              </a:tr>
+              <a:tr h="369824">
+                <a:tc>
+                  <a:txBody>
+                    <a:bodyPr/>
+                    <a:lstStyle/>
+                    <a:p>
+                      <a:r>
+                        <a:rPr sz="1400" b="0" i="0">
+                          <a:solidFill>
+                            <a:srgbClr val="1A1440"/>
+                          </a:solidFill>
+                          <a:latin typeface="Calibri"/>
+                        </a:rPr>
+                        <a:t>[D]</a:t>
+                      </a:r>
+                    </a:p>
+                  </a:txBody>
+                  <a:tcPr marL="101600" marR="101600" marT="38100" marB="38100" anchor="ctr">
+                    <a:solidFill>
+                      <a:srgbClr val="FFFFFF"/>
+                    </a:solidFill>
+                  </a:tcPr>
+                </a:tc>
+                <a:tc>
+                  <a:txBody>
+                    <a:bodyPr/>
+                    <a:lstStyle/>
+                    <a:p>
+                      <a:r>
+                        <a:rPr sz="1400" b="0" i="0">
+                          <a:solidFill>
+                            <a:srgbClr val="1A1440"/>
+                          </a:solidFill>
+                          <a:latin typeface="Calibri"/>
+                        </a:rPr>
+                        <a:t>Your running total closes below the quarter's total: what do you check first?</a:t>
+                      </a:r>
+                    </a:p>
+                  </a:txBody>
+                  <a:tcPr marL="101600" marR="101600" marT="38100" marB="38100" anchor="ctr">
+                    <a:solidFill>
+                      <a:srgbClr val="FFFFFF"/>
+                    </a:solidFill>
+                  </a:tcPr>
+                </a:tc>
+              </a:tr>
+            </a:tbl>
+          </a:graphicData>
+        </a:graphic>
+      </p:graphicFrame>
+      <p:sp>
+        <p:nvSpPr>
+          <p:cNvPr id="11" name="TextBox 10"/>
+          <p:cNvSpPr txBox="1"/>
+          <p:nvPr/>
+        </p:nvSpPr>
+        <p:spPr>
+          <a:xfrm>
+            <a:off x="530352" y="3692144"/>
+            <a:ext cx="11130991" cy="881888"/>
+          </a:xfrm>
+          <a:prstGeom prst="rect">
+            <a:avLst/>
+          </a:prstGeom>
+          <a:noFill/>
+        </p:spPr>
+        <p:txBody>
+          <a:bodyPr wrap="square" anchor="t" lIns="0" rIns="0" tIns="0" bIns="0">
+            <a:spAutoFit/>
+          </a:bodyPr>
+          <a:lstStyle/>
+          <a:p>
+            <a:pPr>
+              <a:spcAft>
+                <a:spcPts val="800"/>
+              </a:spcAft>
+            </a:pPr>
+            <a:r>
+              <a:rPr sz="1600" b="0" i="0">
+                <a:solidFill>
+                  <a:srgbClr val="1A1440"/>
+                </a:solidFill>
+                <a:latin typeface="Calibri"/>
+              </a:rPr>
+              <a:t>Each one asks for a judgment the day's numbers support: the count a tie rule ships, the month with no</a:t>
+            </a:r>
+          </a:p>
+          <a:p>
+            <a:pPr>
+              <a:spcAft>
+                <a:spcPts val="800"/>
+              </a:spcAft>
+            </a:pPr>
+            <a:r>
+              <a:rPr sz="1600" b="0" i="0">
+                <a:solidFill>
+                  <a:srgbClr val="1A1440"/>
+                </a:solidFill>
+                <a:latin typeface="Calibri"/>
+              </a:rPr>
+              <a:t>order, and the running total that has to close on the quarter's own total.</a:t>
+            </a:r>
+          </a:p>
+        </p:txBody>
+      </p:sp>
+      <p:sp>
+        <p:nvSpPr>
+          <p:cNvPr id="12" name="Oval 11"/>
+          <p:cNvSpPr/>
+          <p:nvPr/>
+        </p:nvSpPr>
+        <p:spPr>
+          <a:xfrm>
+            <a:off x="530352" y="6492240"/>
+            <a:ext cx="64008" cy="64008"/>
+          </a:xfrm>
+          <a:prstGeom prst="ellipse">
+            <a:avLst/>
+          </a:prstGeom>
+          <a:solidFill>
+            <a:srgbClr val="CFC9EE"/>
+          </a:solidFill>
+          <a:ln>
+            <a:noFill/>
+          </a:ln>
+          <a:effectLst/>
+        </p:spPr>
+        <p:style>
+          <a:lnRef idx="1">
+            <a:schemeClr val="accent1"/>
+          </a:lnRef>
+          <a:fillRef idx="3">
+            <a:schemeClr val="accent1"/>
+          </a:fillRef>
+          <a:effectRef idx="2">
+            <a:schemeClr val="accent1"/>
+          </a:effectRef>
+          <a:fontRef idx="minor">
+            <a:schemeClr val="lt1"/>
+          </a:fontRef>
+        </p:style>
+        <p:txBody>
+          <a:bodyPr rtlCol="0" anchor="ctr" wrap="square"/>
+          <a:lstStyle/>
+          <a:p>
+            <a:pPr algn="ctr"/>
+          </a:p>
+        </p:txBody>
+      </p:sp>
+      <p:sp>
+        <p:nvSpPr>
+          <p:cNvPr id="13" name="TextBox 12"/>
+          <p:cNvSpPr txBox="1"/>
+          <p:nvPr/>
+        </p:nvSpPr>
+        <p:spPr>
+          <a:xfrm>
+            <a:off x="640080" y="6437376"/>
+            <a:ext cx="1378457" cy="152146"/>
+          </a:xfrm>
+          <a:prstGeom prst="rect">
+            <a:avLst/>
+          </a:prstGeom>
+          <a:noFill/>
+        </p:spPr>
+        <p:txBody>
+          <a:bodyPr wrap="square" anchor="t" lIns="0" rIns="0" tIns="0" bIns="0">
+            <a:spAutoFit/>
+          </a:bodyPr>
+          <a:lstStyle/>
+          <a:p>
+            <a:pPr algn="l"/>
+            <a:r>
+              <a:rPr sz="700" b="0" i="0">
+                <a:solidFill>
+                  <a:srgbClr val="6B6690"/>
+                </a:solidFill>
+                <a:latin typeface="Calibri"/>
+              </a:rPr>
+              <a:t>Who does Marketing call?</a:t>
+            </a:r>
+          </a:p>
+        </p:txBody>
+      </p:sp>
+      <p:sp>
+        <p:nvSpPr>
+          <p:cNvPr id="14" name="Oval 13"/>
+          <p:cNvSpPr/>
+          <p:nvPr/>
+        </p:nvSpPr>
+        <p:spPr>
+          <a:xfrm>
+            <a:off x="2109977" y="6492240"/>
+            <a:ext cx="64008" cy="64008"/>
+          </a:xfrm>
+          <a:prstGeom prst="ellipse">
+            <a:avLst/>
+          </a:prstGeom>
+          <a:solidFill>
+            <a:srgbClr val="CFC9EE"/>
+          </a:solidFill>
+          <a:ln>
+            <a:noFill/>
+          </a:ln>
+          <a:effectLst/>
+        </p:spPr>
+        <p:style>
+          <a:lnRef idx="1">
+            <a:schemeClr val="accent1"/>
+          </a:lnRef>
+          <a:fillRef idx="3">
+            <a:schemeClr val="accent1"/>
+          </a:fillRef>
+          <a:effectRef idx="2">
+            <a:schemeClr val="accent1"/>
+          </a:effectRef>
+          <a:fontRef idx="minor">
+            <a:schemeClr val="lt1"/>
+          </a:fontRef>
+        </p:style>
+        <p:txBody>
+          <a:bodyPr rtlCol="0" anchor="ctr" wrap="square"/>
+          <a:lstStyle/>
+          <a:p>
+            <a:pPr algn="ctr"/>
+          </a:p>
+        </p:txBody>
+      </p:sp>
+      <p:sp>
+        <p:nvSpPr>
+          <p:cNvPr id="15" name="TextBox 14"/>
+          <p:cNvSpPr txBox="1"/>
+          <p:nvPr/>
+        </p:nvSpPr>
+        <p:spPr>
+          <a:xfrm>
+            <a:off x="2219706" y="6437376"/>
+            <a:ext cx="1194435" cy="152146"/>
+          </a:xfrm>
+          <a:prstGeom prst="rect">
+            <a:avLst/>
+          </a:prstGeom>
+          <a:noFill/>
+        </p:spPr>
+        <p:txBody>
+          <a:bodyPr wrap="square" anchor="t" lIns="0" rIns="0" tIns="0" bIns="0">
+            <a:spAutoFit/>
+          </a:bodyPr>
+          <a:lstStyle/>
+          <a:p>
+            <a:pPr algn="l"/>
+            <a:r>
+              <a:rPr sz="700" b="0" i="0">
+                <a:solidFill>
+                  <a:srgbClr val="6B6690"/>
+                </a:solidFill>
+                <a:latin typeface="Calibri"/>
+              </a:rPr>
+              <a:t>Can you do it alone?</a:t>
+            </a:r>
+          </a:p>
+        </p:txBody>
+      </p:sp>
+      <p:sp>
+        <p:nvSpPr>
+          <p:cNvPr id="16" name="Oval 15"/>
+          <p:cNvSpPr/>
+          <p:nvPr/>
+        </p:nvSpPr>
+        <p:spPr>
+          <a:xfrm>
+            <a:off x="3505580" y="6492240"/>
+            <a:ext cx="64008" cy="64008"/>
+          </a:xfrm>
+          <a:prstGeom prst="ellipse">
+            <a:avLst/>
+          </a:prstGeom>
+          <a:solidFill>
+            <a:srgbClr val="5B3FD6"/>
+          </a:solidFill>
+          <a:ln>
+            <a:noFill/>
+          </a:ln>
+          <a:effectLst/>
+        </p:spPr>
+        <p:style>
+          <a:lnRef idx="1">
+            <a:schemeClr val="accent1"/>
+          </a:lnRef>
+          <a:fillRef idx="3">
+            <a:schemeClr val="accent1"/>
+          </a:fillRef>
+          <a:effectRef idx="2">
+            <a:schemeClr val="accent1"/>
+          </a:effectRef>
+          <a:fontRef idx="minor">
+            <a:schemeClr val="lt1"/>
+          </a:fontRef>
+        </p:style>
+        <p:txBody>
+          <a:bodyPr rtlCol="0" anchor="ctr" wrap="square"/>
+          <a:lstStyle/>
+          <a:p>
+            <a:pPr algn="ctr"/>
+          </a:p>
+        </p:txBody>
+      </p:sp>
+      <p:sp>
+        <p:nvSpPr>
+          <p:cNvPr id="17" name="TextBox 16"/>
+          <p:cNvSpPr txBox="1"/>
+          <p:nvPr/>
+        </p:nvSpPr>
+        <p:spPr>
+          <a:xfrm>
+            <a:off x="3615308" y="6437376"/>
+            <a:ext cx="1470469" cy="152146"/>
+          </a:xfrm>
+          <a:prstGeom prst="rect">
+            <a:avLst/>
+          </a:prstGeom>
+          <a:noFill/>
+        </p:spPr>
+        <p:txBody>
+          <a:bodyPr wrap="square" anchor="t" lIns="0" rIns="0" tIns="0" bIns="0">
+            <a:spAutoFit/>
+          </a:bodyPr>
+          <a:lstStyle/>
+          <a:p>
+            <a:pPr algn="l"/>
+            <a:r>
+              <a:rPr sz="700" b="1" i="0">
+                <a:solidFill>
+                  <a:srgbClr val="5B3FD6"/>
+                </a:solidFill>
+                <a:latin typeface="Calibri"/>
+              </a:rPr>
+              <a:t>What do we tell Marketing?</a:t>
+            </a:r>
+          </a:p>
+        </p:txBody>
+      </p:sp>
+      <p:sp>
+        <p:nvSpPr>
+          <p:cNvPr id="18" name="TextBox 17"/>
+          <p:cNvSpPr txBox="1"/>
+          <p:nvPr/>
+        </p:nvSpPr>
+        <p:spPr>
+          <a:xfrm>
+            <a:off x="10198303" y="6437376"/>
+            <a:ext cx="1463040" cy="160401"/>
+          </a:xfrm>
+          <a:prstGeom prst="rect">
+            <a:avLst/>
+          </a:prstGeom>
+          <a:noFill/>
+        </p:spPr>
+        <p:txBody>
+          <a:bodyPr wrap="square" anchor="t" lIns="0" rIns="0" tIns="0" bIns="0">
+            <a:spAutoFit/>
+          </a:bodyPr>
+          <a:lstStyle/>
+          <a:p>
+            <a:pPr algn="r"/>
+            <a:r>
+              <a:rPr sz="750" b="0" i="0">
+                <a:solidFill>
+                  <a:srgbClr val="6B6690"/>
+                </a:solidFill>
+                <a:latin typeface="Calibri"/>
+              </a:rPr>
+              <a:t>D23  ·  27 / 30</a:t>
+            </a:r>
+          </a:p>
+        </p:txBody>
+      </p:sp>
+    </p:spTree>
+  </p:cSld>
+  <p:clrMapOvr>
+    <a:masterClrMapping/>
+  </p:clrMapOvr>
+</p:sld>
+</file>
+
+<file path=ppt/slides/slide28.xml><?xml version="1.0" encoding="utf-8"?>
+<p:sld xmlns:a="http://schemas.openxmlformats.org/drawingml/2006/main" xmlns:p="http://schemas.openxmlformats.org/presentationml/2006/main" xmlns:r="http://schemas.openxmlformats.org/officeDocument/2006/relationships">
+  <p:cSld>
+    <p:spTree>
+      <p:nvGrpSpPr>
+        <p:cNvPr id="1" name=""/>
+        <p:cNvGrpSpPr/>
+        <p:nvPr/>
+      </p:nvGrpSpPr>
+      <p:grpSpPr/>
+      <p:pic>
+        <p:nvPicPr>
+          <p:cNvPr id="2" name="Picture 1" descr="bg_light.jpg"/>
+          <p:cNvPicPr>
+            <a:picLocks noChangeAspect="1"/>
+          </p:cNvPicPr>
+          <p:nvPr/>
+        </p:nvPicPr>
+        <p:blipFill>
+          <a:blip r:embed="rId2"/>
+          <a:stretch>
+            <a:fillRect/>
+          </a:stretch>
+        </p:blipFill>
+        <p:spPr>
+          <a:xfrm>
+            <a:off x="0" y="0"/>
+            <a:ext cx="12191695" cy="6858000"/>
+          </a:xfrm>
+          <a:prstGeom prst="rect">
+            <a:avLst/>
+          </a:prstGeom>
+        </p:spPr>
+      </p:pic>
+      <p:pic>
+        <p:nvPicPr>
+          <p:cNvPr id="3" name="Picture 2" descr="iitgn_logo.png"/>
+          <p:cNvPicPr>
+            <a:picLocks noChangeAspect="1"/>
+          </p:cNvPicPr>
+          <p:nvPr/>
+        </p:nvPicPr>
+        <p:blipFill>
+          <a:blip r:embed="rId3"/>
+          <a:stretch>
+            <a:fillRect/>
+          </a:stretch>
+        </p:blipFill>
+        <p:spPr>
+          <a:xfrm>
+            <a:off x="530352" y="201168"/>
+            <a:ext cx="420624" cy="420624"/>
+          </a:xfrm>
+          <a:prstGeom prst="rect">
+            <a:avLst/>
+          </a:prstGeom>
+        </p:spPr>
+      </p:pic>
+      <p:sp>
+        <p:nvSpPr>
+          <p:cNvPr id="4" name="TextBox 3"/>
+          <p:cNvSpPr txBox="1"/>
+          <p:nvPr/>
+        </p:nvSpPr>
+        <p:spPr>
+          <a:xfrm>
+            <a:off x="1042416" y="228600"/>
+            <a:ext cx="5120640" cy="185166"/>
+          </a:xfrm>
+          <a:prstGeom prst="rect">
+            <a:avLst/>
+          </a:prstGeom>
+          <a:noFill/>
+        </p:spPr>
+        <p:txBody>
+          <a:bodyPr wrap="square" anchor="t" lIns="0" rIns="0" tIns="0" bIns="0">
+            <a:spAutoFit/>
+          </a:bodyPr>
+          <a:lstStyle/>
+          <a:p>
+            <a:pPr algn="l"/>
+            <a:r>
+              <a:rPr sz="900" b="1" i="0">
+                <a:solidFill>
+                  <a:srgbClr val="1A0F5C"/>
+                </a:solidFill>
+                <a:latin typeface="Calibri"/>
+              </a:rPr>
+              <a:t>Indian Institute of Technology Gandhinagar</a:t>
+            </a:r>
+          </a:p>
+        </p:txBody>
+      </p:sp>
+      <p:sp>
+        <p:nvSpPr>
+          <p:cNvPr id="5" name="TextBox 4"/>
+          <p:cNvSpPr txBox="1"/>
+          <p:nvPr/>
+        </p:nvSpPr>
+        <p:spPr>
+          <a:xfrm>
+            <a:off x="1042416" y="420623"/>
+            <a:ext cx="5852160" cy="127381"/>
+          </a:xfrm>
+          <a:prstGeom prst="rect">
+            <a:avLst/>
+          </a:prstGeom>
+          <a:noFill/>
+        </p:spPr>
+        <p:txBody>
+          <a:bodyPr wrap="square" anchor="t" lIns="0" rIns="0" tIns="0" bIns="0">
+            <a:spAutoFit/>
+          </a:bodyPr>
+          <a:lstStyle/>
+          <a:p>
+            <a:pPr algn="l"/>
+            <a:r>
+              <a:rPr sz="550" b="1" i="0" spc="300">
+                <a:solidFill>
+                  <a:srgbClr val="6B6690"/>
+                </a:solidFill>
+                <a:latin typeface="Calibri"/>
+              </a:rPr>
+              <a:t>ADMINISTERED THROUGH THE COMPETENCY ADVANCEMENT ACADEMY</a:t>
+            </a:r>
+          </a:p>
+        </p:txBody>
+      </p:sp>
+      <p:sp>
+        <p:nvSpPr>
+          <p:cNvPr id="6" name="TextBox 5"/>
+          <p:cNvSpPr txBox="1"/>
+          <p:nvPr/>
+        </p:nvSpPr>
+        <p:spPr>
+          <a:xfrm>
+            <a:off x="5992063" y="310896"/>
+            <a:ext cx="5669280" cy="127381"/>
+          </a:xfrm>
+          <a:prstGeom prst="rect">
+            <a:avLst/>
+          </a:prstGeom>
+          <a:noFill/>
+        </p:spPr>
+        <p:txBody>
+          <a:bodyPr wrap="square" anchor="t" lIns="0" rIns="0" tIns="0" bIns="0">
+            <a:spAutoFit/>
+          </a:bodyPr>
+          <a:lstStyle/>
+          <a:p>
+            <a:pPr algn="r"/>
+            <a:r>
+              <a:rPr sz="550" b="1" i="0" spc="300">
+                <a:solidFill>
+                  <a:srgbClr val="6B6690"/>
+                </a:solidFill>
+                <a:latin typeface="Calibri"/>
+              </a:rPr>
+              <a:t>WEEK 2  ·  DAY 3  ·  KALPA GLOBAL CAPABILITY CENTRE</a:t>
+            </a:r>
+          </a:p>
+        </p:txBody>
+      </p:sp>
+      <p:sp>
+        <p:nvSpPr>
+          <p:cNvPr id="7" name="TextBox 6"/>
+          <p:cNvSpPr txBox="1"/>
+          <p:nvPr/>
+        </p:nvSpPr>
+        <p:spPr>
+          <a:xfrm>
+            <a:off x="530352" y="676656"/>
+            <a:ext cx="10033711" cy="512064"/>
+          </a:xfrm>
+          <a:prstGeom prst="rect">
+            <a:avLst/>
+          </a:prstGeom>
+          <a:noFill/>
+        </p:spPr>
+        <p:txBody>
+          <a:bodyPr wrap="square" anchor="b" lIns="0" rIns="0" tIns="0" bIns="0">
+            <a:spAutoFit/>
+          </a:bodyPr>
+          <a:lstStyle/>
+          <a:p>
+            <a:pPr algn="l"/>
+            <a:r>
+              <a:rPr sz="2600" b="0" i="0">
+                <a:solidFill>
+                  <a:srgbClr val="1A0F5C"/>
+                </a:solidFill>
+                <a:latin typeface="Georgia"/>
+              </a:rPr>
               <a:t>The second case, for the take-home: Retail-Core</a:t>
             </a:r>
           </a:p>
@@ -24164,7 +24986,7 @@
       </p:sp>
       <p:pic>
         <p:nvPicPr>
-          <p:cNvPr id="15" name="mermaid diagram" descr="74b5f738e2ac4f9c.png"/>
+          <p:cNvPr id="15" name="mermaid diagram" descr="f626be52d68ee89f.png"/>
           <p:cNvPicPr>
             <a:picLocks noChangeAspect="1"/>
           </p:cNvPicPr>
@@ -24178,8 +25000,8 @@
         </p:blipFill>
         <p:spPr>
           <a:xfrm>
-            <a:off x="780897" y="3502152"/>
-            <a:ext cx="10629900" cy="1600200"/>
+            <a:off x="530352" y="3502152"/>
+            <a:ext cx="11130991" cy="858395"/>
           </a:xfrm>
           <a:prstGeom prst="rect">
             <a:avLst/>
@@ -24453,7 +25275,7 @@
                 </a:solidFill>
                 <a:latin typeface="Calibri"/>
               </a:rPr>
-              <a:t>D23  ·  27 / 29</a:t>
+              <a:t>D24  ·  28 / 30</a:t>
             </a:r>
           </a:p>
         </p:txBody>
@@ -24466,7 +25288,7 @@
 </p:sld>
 </file>
 
-<file path=ppt/slides/slide28.xml><?xml version="1.0" encoding="utf-8"?>
+<file path=ppt/slides/slide29.xml><?xml version="1.0" encoding="utf-8"?>
 <p:sld xmlns:a="http://schemas.openxmlformats.org/drawingml/2006/main" xmlns:p="http://schemas.openxmlformats.org/presentationml/2006/main" xmlns:r="http://schemas.openxmlformats.org/officeDocument/2006/relationships">
   <p:cSld>
     <p:spTree>
@@ -25524,741 +26346,7 @@
                 </a:solidFill>
                 <a:latin typeface="Calibri"/>
               </a:rPr>
-              <a:t>D24  ·  28 / 29</a:t>
-            </a:r>
-          </a:p>
-        </p:txBody>
-      </p:sp>
-    </p:spTree>
-  </p:cSld>
-  <p:clrMapOvr>
-    <a:masterClrMapping/>
-  </p:clrMapOvr>
-</p:sld>
-</file>
-
-<file path=ppt/slides/slide29.xml><?xml version="1.0" encoding="utf-8"?>
-<p:sld xmlns:a="http://schemas.openxmlformats.org/drawingml/2006/main" xmlns:p="http://schemas.openxmlformats.org/presentationml/2006/main" xmlns:r="http://schemas.openxmlformats.org/officeDocument/2006/relationships">
-  <p:cSld>
-    <p:spTree>
-      <p:nvGrpSpPr>
-        <p:cNvPr id="1" name=""/>
-        <p:cNvGrpSpPr/>
-        <p:nvPr/>
-      </p:nvGrpSpPr>
-      <p:grpSpPr/>
-      <p:pic>
-        <p:nvPicPr>
-          <p:cNvPr id="2" name="Picture 1" descr="bg_light.jpg"/>
-          <p:cNvPicPr>
-            <a:picLocks noChangeAspect="1"/>
-          </p:cNvPicPr>
-          <p:nvPr/>
-        </p:nvPicPr>
-        <p:blipFill>
-          <a:blip r:embed="rId2"/>
-          <a:stretch>
-            <a:fillRect/>
-          </a:stretch>
-        </p:blipFill>
-        <p:spPr>
-          <a:xfrm>
-            <a:off x="0" y="0"/>
-            <a:ext cx="12191695" cy="6858000"/>
-          </a:xfrm>
-          <a:prstGeom prst="rect">
-            <a:avLst/>
-          </a:prstGeom>
-        </p:spPr>
-      </p:pic>
-      <p:pic>
-        <p:nvPicPr>
-          <p:cNvPr id="3" name="Picture 2" descr="iitgn_logo.png"/>
-          <p:cNvPicPr>
-            <a:picLocks noChangeAspect="1"/>
-          </p:cNvPicPr>
-          <p:nvPr/>
-        </p:nvPicPr>
-        <p:blipFill>
-          <a:blip r:embed="rId3"/>
-          <a:stretch>
-            <a:fillRect/>
-          </a:stretch>
-        </p:blipFill>
-        <p:spPr>
-          <a:xfrm>
-            <a:off x="530352" y="201168"/>
-            <a:ext cx="420624" cy="420624"/>
-          </a:xfrm>
-          <a:prstGeom prst="rect">
-            <a:avLst/>
-          </a:prstGeom>
-        </p:spPr>
-      </p:pic>
-      <p:sp>
-        <p:nvSpPr>
-          <p:cNvPr id="4" name="TextBox 3"/>
-          <p:cNvSpPr txBox="1"/>
-          <p:nvPr/>
-        </p:nvSpPr>
-        <p:spPr>
-          <a:xfrm>
-            <a:off x="1042416" y="228600"/>
-            <a:ext cx="5120640" cy="185166"/>
-          </a:xfrm>
-          <a:prstGeom prst="rect">
-            <a:avLst/>
-          </a:prstGeom>
-          <a:noFill/>
-        </p:spPr>
-        <p:txBody>
-          <a:bodyPr wrap="square" anchor="t" lIns="0" rIns="0" tIns="0" bIns="0">
-            <a:spAutoFit/>
-          </a:bodyPr>
-          <a:lstStyle/>
-          <a:p>
-            <a:pPr algn="l"/>
-            <a:r>
-              <a:rPr sz="900" b="1" i="0">
-                <a:solidFill>
-                  <a:srgbClr val="1A0F5C"/>
-                </a:solidFill>
-                <a:latin typeface="Calibri"/>
-              </a:rPr>
-              <a:t>Indian Institute of Technology Gandhinagar</a:t>
-            </a:r>
-          </a:p>
-        </p:txBody>
-      </p:sp>
-      <p:sp>
-        <p:nvSpPr>
-          <p:cNvPr id="5" name="TextBox 4"/>
-          <p:cNvSpPr txBox="1"/>
-          <p:nvPr/>
-        </p:nvSpPr>
-        <p:spPr>
-          <a:xfrm>
-            <a:off x="1042416" y="420623"/>
-            <a:ext cx="5852160" cy="127381"/>
-          </a:xfrm>
-          <a:prstGeom prst="rect">
-            <a:avLst/>
-          </a:prstGeom>
-          <a:noFill/>
-        </p:spPr>
-        <p:txBody>
-          <a:bodyPr wrap="square" anchor="t" lIns="0" rIns="0" tIns="0" bIns="0">
-            <a:spAutoFit/>
-          </a:bodyPr>
-          <a:lstStyle/>
-          <a:p>
-            <a:pPr algn="l"/>
-            <a:r>
-              <a:rPr sz="550" b="1" i="0" spc="300">
-                <a:solidFill>
-                  <a:srgbClr val="6B6690"/>
-                </a:solidFill>
-                <a:latin typeface="Calibri"/>
-              </a:rPr>
-              <a:t>ADMINISTERED THROUGH THE COMPETENCY ADVANCEMENT ACADEMY</a:t>
-            </a:r>
-          </a:p>
-        </p:txBody>
-      </p:sp>
-      <p:sp>
-        <p:nvSpPr>
-          <p:cNvPr id="6" name="TextBox 5"/>
-          <p:cNvSpPr txBox="1"/>
-          <p:nvPr/>
-        </p:nvSpPr>
-        <p:spPr>
-          <a:xfrm>
-            <a:off x="5992063" y="310896"/>
-            <a:ext cx="5669280" cy="127381"/>
-          </a:xfrm>
-          <a:prstGeom prst="rect">
-            <a:avLst/>
-          </a:prstGeom>
-          <a:noFill/>
-        </p:spPr>
-        <p:txBody>
-          <a:bodyPr wrap="square" anchor="t" lIns="0" rIns="0" tIns="0" bIns="0">
-            <a:spAutoFit/>
-          </a:bodyPr>
-          <a:lstStyle/>
-          <a:p>
-            <a:pPr algn="r"/>
-            <a:r>
-              <a:rPr sz="550" b="1" i="0" spc="300">
-                <a:solidFill>
-                  <a:srgbClr val="6B6690"/>
-                </a:solidFill>
-                <a:latin typeface="Calibri"/>
-              </a:rPr>
-              <a:t>WEEK 2  ·  DAY 3  ·  KALPA GLOBAL CAPABILITY CENTRE</a:t>
-            </a:r>
-          </a:p>
-        </p:txBody>
-      </p:sp>
-      <p:sp>
-        <p:nvSpPr>
-          <p:cNvPr id="7" name="TextBox 6"/>
-          <p:cNvSpPr txBox="1"/>
-          <p:nvPr/>
-        </p:nvSpPr>
-        <p:spPr>
-          <a:xfrm>
-            <a:off x="530352" y="676656"/>
-            <a:ext cx="11130991" cy="512064"/>
-          </a:xfrm>
-          <a:prstGeom prst="rect">
-            <a:avLst/>
-          </a:prstGeom>
-          <a:noFill/>
-        </p:spPr>
-        <p:txBody>
-          <a:bodyPr wrap="square" anchor="b" lIns="0" rIns="0" tIns="0" bIns="0">
-            <a:spAutoFit/>
-          </a:bodyPr>
-          <a:lstStyle/>
-          <a:p>
-            <a:pPr algn="l"/>
-            <a:r>
-              <a:rPr sz="2600" b="0" i="0">
-                <a:solidFill>
-                  <a:srgbClr val="1A0F5C"/>
-                </a:solidFill>
-                <a:latin typeface="Georgia"/>
-              </a:rPr>
-              <a:t>Tomorrow: one table per customer, left open</a:t>
-            </a:r>
-          </a:p>
-        </p:txBody>
-      </p:sp>
-      <p:sp>
-        <p:nvSpPr>
-          <p:cNvPr id="8" name="TextBox 7"/>
-          <p:cNvSpPr txBox="1"/>
-          <p:nvPr/>
-        </p:nvSpPr>
-        <p:spPr>
-          <a:xfrm>
-            <a:off x="530352" y="1243584"/>
-            <a:ext cx="11130991" cy="234696"/>
-          </a:xfrm>
-          <a:prstGeom prst="rect">
-            <a:avLst/>
-          </a:prstGeom>
-          <a:noFill/>
-        </p:spPr>
-        <p:txBody>
-          <a:bodyPr wrap="square" anchor="t" lIns="0" rIns="0" tIns="0" bIns="0">
-            <a:spAutoFit/>
-          </a:bodyPr>
-          <a:lstStyle/>
-          <a:p>
-            <a:pPr algn="l"/>
-            <a:r>
-              <a:rPr sz="1200" b="0" i="0">
-                <a:solidFill>
-                  <a:srgbClr val="6B6690"/>
-                </a:solidFill>
-                <a:latin typeface="Calibri"/>
-              </a:rPr>
-              <a:t>The growth team asks the next question: what does Marketing's own table look like?</a:t>
-            </a:r>
-          </a:p>
-        </p:txBody>
-      </p:sp>
-      <p:sp>
-        <p:nvSpPr>
-          <p:cNvPr id="9" name="Rounded Rectangle 8"/>
-          <p:cNvSpPr/>
-          <p:nvPr/>
-        </p:nvSpPr>
-        <p:spPr>
-          <a:xfrm>
-            <a:off x="530352" y="1956816"/>
-            <a:ext cx="11130991" cy="1121664"/>
-          </a:xfrm>
-          <a:prstGeom prst="roundRect">
-            <a:avLst>
-              <a:gd name="adj" fmla="val 5000"/>
-            </a:avLst>
-          </a:prstGeom>
-          <a:gradFill rotWithShape="1">
-            <a:gsLst>
-              <a:gs pos="0">
-                <a:srgbClr val="2C1A86"/>
-              </a:gs>
-              <a:gs pos="100000">
-                <a:srgbClr val="1A0F5C"/>
-              </a:gs>
-            </a:gsLst>
-            <a:lin scaled="0" ang="16200000"/>
-          </a:gradFill>
-          <a:ln>
-            <a:noFill/>
-          </a:ln>
-          <a:effectLst>
-            <a:outerShdw blurRad="76200" dist="19050" dir="5400000" algn="bl" rotWithShape="0">
-              <a:srgbClr val="1A0F5C">
-                <a:alpha val="12000"/>
-              </a:srgbClr>
-            </a:outerShdw>
-          </a:effectLst>
-        </p:spPr>
-        <p:style>
-          <a:lnRef idx="1">
-            <a:schemeClr val="accent1"/>
-          </a:lnRef>
-          <a:fillRef idx="3">
-            <a:schemeClr val="accent1"/>
-          </a:fillRef>
-          <a:effectRef idx="2">
-            <a:schemeClr val="accent1"/>
-          </a:effectRef>
-          <a:fontRef idx="minor">
-            <a:schemeClr val="lt1"/>
-          </a:fontRef>
-        </p:style>
-        <p:txBody>
-          <a:bodyPr rtlCol="0" anchor="ctr" wrap="square"/>
-          <a:lstStyle/>
-          <a:p>
-            <a:pPr algn="ctr"/>
-          </a:p>
-        </p:txBody>
-      </p:sp>
-      <p:sp>
-        <p:nvSpPr>
-          <p:cNvPr id="10" name="Oval 9"/>
-          <p:cNvSpPr/>
-          <p:nvPr/>
-        </p:nvSpPr>
-        <p:spPr>
-          <a:xfrm>
-            <a:off x="758952" y="2289048"/>
-            <a:ext cx="457200" cy="457200"/>
-          </a:xfrm>
-          <a:prstGeom prst="ellipse">
-            <a:avLst/>
-          </a:prstGeom>
-          <a:solidFill>
-            <a:srgbClr val="5B3FD6"/>
-          </a:solidFill>
-          <a:ln>
-            <a:noFill/>
-          </a:ln>
-          <a:effectLst/>
-        </p:spPr>
-        <p:style>
-          <a:lnRef idx="1">
-            <a:schemeClr val="accent1"/>
-          </a:lnRef>
-          <a:fillRef idx="3">
-            <a:schemeClr val="accent1"/>
-          </a:fillRef>
-          <a:effectRef idx="2">
-            <a:schemeClr val="accent1"/>
-          </a:effectRef>
-          <a:fontRef idx="minor">
-            <a:schemeClr val="lt1"/>
-          </a:fontRef>
-        </p:style>
-        <p:txBody>
-          <a:bodyPr rtlCol="0" anchor="ctr" wrap="square"/>
-          <a:lstStyle/>
-          <a:p>
-            <a:pPr algn="ctr"/>
-          </a:p>
-        </p:txBody>
-      </p:sp>
-      <p:pic>
-        <p:nvPicPr>
-          <p:cNvPr id="11" name="Picture 10" descr="message-square_028dbd132a0a.png"/>
-          <p:cNvPicPr>
-            <a:picLocks noChangeAspect="1"/>
-          </p:cNvPicPr>
-          <p:nvPr/>
-        </p:nvPicPr>
-        <p:blipFill>
-          <a:blip r:embed="rId4"/>
-          <a:stretch>
-            <a:fillRect/>
-          </a:stretch>
-        </p:blipFill>
-        <p:spPr>
-          <a:xfrm>
-            <a:off x="868680" y="2398776"/>
-            <a:ext cx="237744" cy="237744"/>
-          </a:xfrm>
-          <a:prstGeom prst="rect">
-            <a:avLst/>
-          </a:prstGeom>
-        </p:spPr>
-      </p:pic>
-      <p:sp>
-        <p:nvSpPr>
-          <p:cNvPr id="12" name="TextBox 11"/>
-          <p:cNvSpPr txBox="1"/>
-          <p:nvPr/>
-        </p:nvSpPr>
-        <p:spPr>
-          <a:xfrm>
-            <a:off x="1399031" y="2103120"/>
-            <a:ext cx="9987991" cy="160401"/>
-          </a:xfrm>
-          <a:prstGeom prst="rect">
-            <a:avLst/>
-          </a:prstGeom>
-          <a:noFill/>
-        </p:spPr>
-        <p:txBody>
-          <a:bodyPr wrap="square" anchor="t" lIns="0" rIns="0" tIns="0" bIns="0">
-            <a:spAutoFit/>
-          </a:bodyPr>
-          <a:lstStyle/>
-          <a:p>
-            <a:pPr algn="l"/>
-            <a:r>
-              <a:rPr sz="750" b="1" i="0" spc="250">
-                <a:solidFill>
-                  <a:srgbClr val="D9A7FF"/>
-                </a:solidFill>
-                <a:latin typeface="Calibri"/>
-              </a:rPr>
-              <a:t>THE CLIENT ASKS</a:t>
-            </a:r>
-          </a:p>
-        </p:txBody>
-      </p:sp>
-      <p:sp>
-        <p:nvSpPr>
-          <p:cNvPr id="13" name="TextBox 12"/>
-          <p:cNvSpPr txBox="1"/>
-          <p:nvPr/>
-        </p:nvSpPr>
-        <p:spPr>
-          <a:xfrm>
-            <a:off x="1399031" y="2322576"/>
-            <a:ext cx="9987991" cy="682752"/>
-          </a:xfrm>
-          <a:prstGeom prst="rect">
-            <a:avLst/>
-          </a:prstGeom>
-          <a:noFill/>
-        </p:spPr>
-        <p:txBody>
-          <a:bodyPr wrap="square" anchor="t" lIns="0" rIns="0" tIns="0" bIns="0">
-            <a:spAutoFit/>
-          </a:bodyPr>
-          <a:lstStyle/>
-          <a:p>
-            <a:r>
-              <a:rPr sz="1500" b="0" i="0">
-                <a:solidFill>
-                  <a:srgbClr val="FFFFFF"/>
-                </a:solidFill>
-                <a:latin typeface="Calibri"/>
-              </a:rPr>
-              <a:t>"We want one table with one row per customer, refreshed every Monday: how recently they bought, how often, how much, their segment, whether the monsoon sale reached them, and last week's flags."</a:t>
-            </a:r>
-          </a:p>
-        </p:txBody>
-      </p:sp>
-      <p:pic>
-        <p:nvPicPr>
-          <p:cNvPr id="14" name="mermaid diagram" descr="7c7d2ba252e30238.png"/>
-          <p:cNvPicPr>
-            <a:picLocks noChangeAspect="1"/>
-          </p:cNvPicPr>
-          <p:nvPr/>
-        </p:nvPicPr>
-        <p:blipFill>
-          <a:blip r:embed="rId6"/>
-          <a:stretch>
-            <a:fillRect/>
-          </a:stretch>
-        </p:blipFill>
-        <p:spPr>
-          <a:xfrm>
-            <a:off x="2152497" y="3243072"/>
-            <a:ext cx="7886700" cy="1857375"/>
-          </a:xfrm>
-          <a:prstGeom prst="rect">
-            <a:avLst/>
-          </a:prstGeom>
-        </p:spPr>
-      </p:pic>
-      <p:sp>
-        <p:nvSpPr>
-          <p:cNvPr id="15" name="Oval 14"/>
-          <p:cNvSpPr/>
-          <p:nvPr/>
-        </p:nvSpPr>
-        <p:spPr>
-          <a:xfrm>
-            <a:off x="530352" y="6492240"/>
-            <a:ext cx="64008" cy="64008"/>
-          </a:xfrm>
-          <a:prstGeom prst="ellipse">
-            <a:avLst/>
-          </a:prstGeom>
-          <a:solidFill>
-            <a:srgbClr val="CFC9EE"/>
-          </a:solidFill>
-          <a:ln>
-            <a:noFill/>
-          </a:ln>
-          <a:effectLst/>
-        </p:spPr>
-        <p:style>
-          <a:lnRef idx="1">
-            <a:schemeClr val="accent1"/>
-          </a:lnRef>
-          <a:fillRef idx="3">
-            <a:schemeClr val="accent1"/>
-          </a:fillRef>
-          <a:effectRef idx="2">
-            <a:schemeClr val="accent1"/>
-          </a:effectRef>
-          <a:fontRef idx="minor">
-            <a:schemeClr val="lt1"/>
-          </a:fontRef>
-        </p:style>
-        <p:txBody>
-          <a:bodyPr rtlCol="0" anchor="ctr" wrap="square"/>
-          <a:lstStyle/>
-          <a:p>
-            <a:pPr algn="ctr"/>
-          </a:p>
-        </p:txBody>
-      </p:sp>
-      <p:sp>
-        <p:nvSpPr>
-          <p:cNvPr id="16" name="TextBox 15"/>
-          <p:cNvSpPr txBox="1"/>
-          <p:nvPr/>
-        </p:nvSpPr>
-        <p:spPr>
-          <a:xfrm>
-            <a:off x="640080" y="6437376"/>
-            <a:ext cx="1378457" cy="152146"/>
-          </a:xfrm>
-          <a:prstGeom prst="rect">
-            <a:avLst/>
-          </a:prstGeom>
-          <a:noFill/>
-        </p:spPr>
-        <p:txBody>
-          <a:bodyPr wrap="square" anchor="t" lIns="0" rIns="0" tIns="0" bIns="0">
-            <a:spAutoFit/>
-          </a:bodyPr>
-          <a:lstStyle/>
-          <a:p>
-            <a:pPr algn="l"/>
-            <a:r>
-              <a:rPr sz="700" b="0" i="0">
-                <a:solidFill>
-                  <a:srgbClr val="6B6690"/>
-                </a:solidFill>
-                <a:latin typeface="Calibri"/>
-              </a:rPr>
-              <a:t>Who does Marketing call?</a:t>
-            </a:r>
-          </a:p>
-        </p:txBody>
-      </p:sp>
-      <p:sp>
-        <p:nvSpPr>
-          <p:cNvPr id="17" name="Oval 16"/>
-          <p:cNvSpPr/>
-          <p:nvPr/>
-        </p:nvSpPr>
-        <p:spPr>
-          <a:xfrm>
-            <a:off x="2109977" y="6492240"/>
-            <a:ext cx="64008" cy="64008"/>
-          </a:xfrm>
-          <a:prstGeom prst="ellipse">
-            <a:avLst/>
-          </a:prstGeom>
-          <a:solidFill>
-            <a:srgbClr val="CFC9EE"/>
-          </a:solidFill>
-          <a:ln>
-            <a:noFill/>
-          </a:ln>
-          <a:effectLst/>
-        </p:spPr>
-        <p:style>
-          <a:lnRef idx="1">
-            <a:schemeClr val="accent1"/>
-          </a:lnRef>
-          <a:fillRef idx="3">
-            <a:schemeClr val="accent1"/>
-          </a:fillRef>
-          <a:effectRef idx="2">
-            <a:schemeClr val="accent1"/>
-          </a:effectRef>
-          <a:fontRef idx="minor">
-            <a:schemeClr val="lt1"/>
-          </a:fontRef>
-        </p:style>
-        <p:txBody>
-          <a:bodyPr rtlCol="0" anchor="ctr" wrap="square"/>
-          <a:lstStyle/>
-          <a:p>
-            <a:pPr algn="ctr"/>
-          </a:p>
-        </p:txBody>
-      </p:sp>
-      <p:sp>
-        <p:nvSpPr>
-          <p:cNvPr id="18" name="TextBox 17"/>
-          <p:cNvSpPr txBox="1"/>
-          <p:nvPr/>
-        </p:nvSpPr>
-        <p:spPr>
-          <a:xfrm>
-            <a:off x="2219706" y="6437376"/>
-            <a:ext cx="1194435" cy="152146"/>
-          </a:xfrm>
-          <a:prstGeom prst="rect">
-            <a:avLst/>
-          </a:prstGeom>
-          <a:noFill/>
-        </p:spPr>
-        <p:txBody>
-          <a:bodyPr wrap="square" anchor="t" lIns="0" rIns="0" tIns="0" bIns="0">
-            <a:spAutoFit/>
-          </a:bodyPr>
-          <a:lstStyle/>
-          <a:p>
-            <a:pPr algn="l"/>
-            <a:r>
-              <a:rPr sz="700" b="0" i="0">
-                <a:solidFill>
-                  <a:srgbClr val="6B6690"/>
-                </a:solidFill>
-                <a:latin typeface="Calibri"/>
-              </a:rPr>
-              <a:t>Can you do it alone?</a:t>
-            </a:r>
-          </a:p>
-        </p:txBody>
-      </p:sp>
-      <p:sp>
-        <p:nvSpPr>
-          <p:cNvPr id="19" name="Oval 18"/>
-          <p:cNvSpPr/>
-          <p:nvPr/>
-        </p:nvSpPr>
-        <p:spPr>
-          <a:xfrm>
-            <a:off x="3505580" y="6492240"/>
-            <a:ext cx="64008" cy="64008"/>
-          </a:xfrm>
-          <a:prstGeom prst="ellipse">
-            <a:avLst/>
-          </a:prstGeom>
-          <a:solidFill>
-            <a:srgbClr val="5B3FD6"/>
-          </a:solidFill>
-          <a:ln>
-            <a:noFill/>
-          </a:ln>
-          <a:effectLst/>
-        </p:spPr>
-        <p:style>
-          <a:lnRef idx="1">
-            <a:schemeClr val="accent1"/>
-          </a:lnRef>
-          <a:fillRef idx="3">
-            <a:schemeClr val="accent1"/>
-          </a:fillRef>
-          <a:effectRef idx="2">
-            <a:schemeClr val="accent1"/>
-          </a:effectRef>
-          <a:fontRef idx="minor">
-            <a:schemeClr val="lt1"/>
-          </a:fontRef>
-        </p:style>
-        <p:txBody>
-          <a:bodyPr rtlCol="0" anchor="ctr" wrap="square"/>
-          <a:lstStyle/>
-          <a:p>
-            <a:pPr algn="ctr"/>
-          </a:p>
-        </p:txBody>
-      </p:sp>
-      <p:sp>
-        <p:nvSpPr>
-          <p:cNvPr id="20" name="TextBox 19"/>
-          <p:cNvSpPr txBox="1"/>
-          <p:nvPr/>
-        </p:nvSpPr>
-        <p:spPr>
-          <a:xfrm>
-            <a:off x="3615308" y="6437376"/>
-            <a:ext cx="1470469" cy="152146"/>
-          </a:xfrm>
-          <a:prstGeom prst="rect">
-            <a:avLst/>
-          </a:prstGeom>
-          <a:noFill/>
-        </p:spPr>
-        <p:txBody>
-          <a:bodyPr wrap="square" anchor="t" lIns="0" rIns="0" tIns="0" bIns="0">
-            <a:spAutoFit/>
-          </a:bodyPr>
-          <a:lstStyle/>
-          <a:p>
-            <a:pPr algn="l"/>
-            <a:r>
-              <a:rPr sz="700" b="1" i="0">
-                <a:solidFill>
-                  <a:srgbClr val="5B3FD6"/>
-                </a:solidFill>
-                <a:latin typeface="Calibri"/>
-              </a:rPr>
-              <a:t>What do we tell Marketing?</a:t>
-            </a:r>
-          </a:p>
-        </p:txBody>
-      </p:sp>
-      <p:sp>
-        <p:nvSpPr>
-          <p:cNvPr id="21" name="TextBox 20"/>
-          <p:cNvSpPr txBox="1"/>
-          <p:nvPr/>
-        </p:nvSpPr>
-        <p:spPr>
-          <a:xfrm>
-            <a:off x="10198303" y="6437376"/>
-            <a:ext cx="1463040" cy="160401"/>
-          </a:xfrm>
-          <a:prstGeom prst="rect">
-            <a:avLst/>
-          </a:prstGeom>
-          <a:noFill/>
-        </p:spPr>
-        <p:txBody>
-          <a:bodyPr wrap="square" anchor="t" lIns="0" rIns="0" tIns="0" bIns="0">
-            <a:spAutoFit/>
-          </a:bodyPr>
-          <a:lstStyle/>
-          <a:p>
-            <a:pPr algn="r"/>
-            <a:r>
-              <a:rPr sz="750" b="0" i="0">
-                <a:solidFill>
-                  <a:srgbClr val="6B6690"/>
-                </a:solidFill>
-                <a:latin typeface="Calibri"/>
-              </a:rPr>
-              <a:t>S25  ·  29 / 29</a:t>
+              <a:t>D25  ·  29 / 30</a:t>
             </a:r>
           </a:p>
         </p:txBody>
@@ -26534,7 +26622,7 @@
                 </a:solidFill>
                 <a:latin typeface="Calibri"/>
               </a:rPr>
-              <a:t>Which listed members does Marketing call first, and does each flag hold up when a member says he was on holiday?</a:t>
+              <a:t>Which listed members does Marketing call first, and does each flag hold up when a member says they were on holiday?</a:t>
             </a:r>
           </a:p>
         </p:txBody>
@@ -26769,7 +26857,741 @@
                 </a:solidFill>
                 <a:latin typeface="Calibri"/>
               </a:rPr>
-              <a:t>3 / 29</a:t>
+              <a:t>3 / 30</a:t>
+            </a:r>
+          </a:p>
+        </p:txBody>
+      </p:sp>
+    </p:spTree>
+  </p:cSld>
+  <p:clrMapOvr>
+    <a:masterClrMapping/>
+  </p:clrMapOvr>
+</p:sld>
+</file>
+
+<file path=ppt/slides/slide30.xml><?xml version="1.0" encoding="utf-8"?>
+<p:sld xmlns:a="http://schemas.openxmlformats.org/drawingml/2006/main" xmlns:p="http://schemas.openxmlformats.org/presentationml/2006/main" xmlns:r="http://schemas.openxmlformats.org/officeDocument/2006/relationships">
+  <p:cSld>
+    <p:spTree>
+      <p:nvGrpSpPr>
+        <p:cNvPr id="1" name=""/>
+        <p:cNvGrpSpPr/>
+        <p:nvPr/>
+      </p:nvGrpSpPr>
+      <p:grpSpPr/>
+      <p:pic>
+        <p:nvPicPr>
+          <p:cNvPr id="2" name="Picture 1" descr="bg_light.jpg"/>
+          <p:cNvPicPr>
+            <a:picLocks noChangeAspect="1"/>
+          </p:cNvPicPr>
+          <p:nvPr/>
+        </p:nvPicPr>
+        <p:blipFill>
+          <a:blip r:embed="rId2"/>
+          <a:stretch>
+            <a:fillRect/>
+          </a:stretch>
+        </p:blipFill>
+        <p:spPr>
+          <a:xfrm>
+            <a:off x="0" y="0"/>
+            <a:ext cx="12191695" cy="6858000"/>
+          </a:xfrm>
+          <a:prstGeom prst="rect">
+            <a:avLst/>
+          </a:prstGeom>
+        </p:spPr>
+      </p:pic>
+      <p:pic>
+        <p:nvPicPr>
+          <p:cNvPr id="3" name="Picture 2" descr="iitgn_logo.png"/>
+          <p:cNvPicPr>
+            <a:picLocks noChangeAspect="1"/>
+          </p:cNvPicPr>
+          <p:nvPr/>
+        </p:nvPicPr>
+        <p:blipFill>
+          <a:blip r:embed="rId3"/>
+          <a:stretch>
+            <a:fillRect/>
+          </a:stretch>
+        </p:blipFill>
+        <p:spPr>
+          <a:xfrm>
+            <a:off x="530352" y="201168"/>
+            <a:ext cx="420624" cy="420624"/>
+          </a:xfrm>
+          <a:prstGeom prst="rect">
+            <a:avLst/>
+          </a:prstGeom>
+        </p:spPr>
+      </p:pic>
+      <p:sp>
+        <p:nvSpPr>
+          <p:cNvPr id="4" name="TextBox 3"/>
+          <p:cNvSpPr txBox="1"/>
+          <p:nvPr/>
+        </p:nvSpPr>
+        <p:spPr>
+          <a:xfrm>
+            <a:off x="1042416" y="228600"/>
+            <a:ext cx="5120640" cy="185166"/>
+          </a:xfrm>
+          <a:prstGeom prst="rect">
+            <a:avLst/>
+          </a:prstGeom>
+          <a:noFill/>
+        </p:spPr>
+        <p:txBody>
+          <a:bodyPr wrap="square" anchor="t" lIns="0" rIns="0" tIns="0" bIns="0">
+            <a:spAutoFit/>
+          </a:bodyPr>
+          <a:lstStyle/>
+          <a:p>
+            <a:pPr algn="l"/>
+            <a:r>
+              <a:rPr sz="900" b="1" i="0">
+                <a:solidFill>
+                  <a:srgbClr val="1A0F5C"/>
+                </a:solidFill>
+                <a:latin typeface="Calibri"/>
+              </a:rPr>
+              <a:t>Indian Institute of Technology Gandhinagar</a:t>
+            </a:r>
+          </a:p>
+        </p:txBody>
+      </p:sp>
+      <p:sp>
+        <p:nvSpPr>
+          <p:cNvPr id="5" name="TextBox 4"/>
+          <p:cNvSpPr txBox="1"/>
+          <p:nvPr/>
+        </p:nvSpPr>
+        <p:spPr>
+          <a:xfrm>
+            <a:off x="1042416" y="420623"/>
+            <a:ext cx="5852160" cy="127381"/>
+          </a:xfrm>
+          <a:prstGeom prst="rect">
+            <a:avLst/>
+          </a:prstGeom>
+          <a:noFill/>
+        </p:spPr>
+        <p:txBody>
+          <a:bodyPr wrap="square" anchor="t" lIns="0" rIns="0" tIns="0" bIns="0">
+            <a:spAutoFit/>
+          </a:bodyPr>
+          <a:lstStyle/>
+          <a:p>
+            <a:pPr algn="l"/>
+            <a:r>
+              <a:rPr sz="550" b="1" i="0" spc="300">
+                <a:solidFill>
+                  <a:srgbClr val="6B6690"/>
+                </a:solidFill>
+                <a:latin typeface="Calibri"/>
+              </a:rPr>
+              <a:t>ADMINISTERED THROUGH THE COMPETENCY ADVANCEMENT ACADEMY</a:t>
+            </a:r>
+          </a:p>
+        </p:txBody>
+      </p:sp>
+      <p:sp>
+        <p:nvSpPr>
+          <p:cNvPr id="6" name="TextBox 5"/>
+          <p:cNvSpPr txBox="1"/>
+          <p:nvPr/>
+        </p:nvSpPr>
+        <p:spPr>
+          <a:xfrm>
+            <a:off x="5992063" y="310896"/>
+            <a:ext cx="5669280" cy="127381"/>
+          </a:xfrm>
+          <a:prstGeom prst="rect">
+            <a:avLst/>
+          </a:prstGeom>
+          <a:noFill/>
+        </p:spPr>
+        <p:txBody>
+          <a:bodyPr wrap="square" anchor="t" lIns="0" rIns="0" tIns="0" bIns="0">
+            <a:spAutoFit/>
+          </a:bodyPr>
+          <a:lstStyle/>
+          <a:p>
+            <a:pPr algn="r"/>
+            <a:r>
+              <a:rPr sz="550" b="1" i="0" spc="300">
+                <a:solidFill>
+                  <a:srgbClr val="6B6690"/>
+                </a:solidFill>
+                <a:latin typeface="Calibri"/>
+              </a:rPr>
+              <a:t>WEEK 2  ·  DAY 3  ·  KALPA GLOBAL CAPABILITY CENTRE</a:t>
+            </a:r>
+          </a:p>
+        </p:txBody>
+      </p:sp>
+      <p:sp>
+        <p:nvSpPr>
+          <p:cNvPr id="7" name="TextBox 6"/>
+          <p:cNvSpPr txBox="1"/>
+          <p:nvPr/>
+        </p:nvSpPr>
+        <p:spPr>
+          <a:xfrm>
+            <a:off x="530352" y="676656"/>
+            <a:ext cx="11130991" cy="512064"/>
+          </a:xfrm>
+          <a:prstGeom prst="rect">
+            <a:avLst/>
+          </a:prstGeom>
+          <a:noFill/>
+        </p:spPr>
+        <p:txBody>
+          <a:bodyPr wrap="square" anchor="b" lIns="0" rIns="0" tIns="0" bIns="0">
+            <a:spAutoFit/>
+          </a:bodyPr>
+          <a:lstStyle/>
+          <a:p>
+            <a:pPr algn="l"/>
+            <a:r>
+              <a:rPr sz="2600" b="0" i="0">
+                <a:solidFill>
+                  <a:srgbClr val="1A0F5C"/>
+                </a:solidFill>
+                <a:latin typeface="Georgia"/>
+              </a:rPr>
+              <a:t>Tomorrow: one table per customer, left open</a:t>
+            </a:r>
+          </a:p>
+        </p:txBody>
+      </p:sp>
+      <p:sp>
+        <p:nvSpPr>
+          <p:cNvPr id="8" name="TextBox 7"/>
+          <p:cNvSpPr txBox="1"/>
+          <p:nvPr/>
+        </p:nvSpPr>
+        <p:spPr>
+          <a:xfrm>
+            <a:off x="530352" y="1243584"/>
+            <a:ext cx="11130991" cy="234696"/>
+          </a:xfrm>
+          <a:prstGeom prst="rect">
+            <a:avLst/>
+          </a:prstGeom>
+          <a:noFill/>
+        </p:spPr>
+        <p:txBody>
+          <a:bodyPr wrap="square" anchor="t" lIns="0" rIns="0" tIns="0" bIns="0">
+            <a:spAutoFit/>
+          </a:bodyPr>
+          <a:lstStyle/>
+          <a:p>
+            <a:pPr algn="l"/>
+            <a:r>
+              <a:rPr sz="1200" b="0" i="0">
+                <a:solidFill>
+                  <a:srgbClr val="6B6690"/>
+                </a:solidFill>
+                <a:latin typeface="Calibri"/>
+              </a:rPr>
+              <a:t>The growth team asks the next question: what does Marketing's own table look like?</a:t>
+            </a:r>
+          </a:p>
+        </p:txBody>
+      </p:sp>
+      <p:sp>
+        <p:nvSpPr>
+          <p:cNvPr id="9" name="Rounded Rectangle 8"/>
+          <p:cNvSpPr/>
+          <p:nvPr/>
+        </p:nvSpPr>
+        <p:spPr>
+          <a:xfrm>
+            <a:off x="530352" y="1956816"/>
+            <a:ext cx="11130991" cy="1121664"/>
+          </a:xfrm>
+          <a:prstGeom prst="roundRect">
+            <a:avLst>
+              <a:gd name="adj" fmla="val 5000"/>
+            </a:avLst>
+          </a:prstGeom>
+          <a:gradFill rotWithShape="1">
+            <a:gsLst>
+              <a:gs pos="0">
+                <a:srgbClr val="2C1A86"/>
+              </a:gs>
+              <a:gs pos="100000">
+                <a:srgbClr val="1A0F5C"/>
+              </a:gs>
+            </a:gsLst>
+            <a:lin scaled="0" ang="16200000"/>
+          </a:gradFill>
+          <a:ln>
+            <a:noFill/>
+          </a:ln>
+          <a:effectLst>
+            <a:outerShdw blurRad="76200" dist="19050" dir="5400000" algn="bl" rotWithShape="0">
+              <a:srgbClr val="1A0F5C">
+                <a:alpha val="12000"/>
+              </a:srgbClr>
+            </a:outerShdw>
+          </a:effectLst>
+        </p:spPr>
+        <p:style>
+          <a:lnRef idx="1">
+            <a:schemeClr val="accent1"/>
+          </a:lnRef>
+          <a:fillRef idx="3">
+            <a:schemeClr val="accent1"/>
+          </a:fillRef>
+          <a:effectRef idx="2">
+            <a:schemeClr val="accent1"/>
+          </a:effectRef>
+          <a:fontRef idx="minor">
+            <a:schemeClr val="lt1"/>
+          </a:fontRef>
+        </p:style>
+        <p:txBody>
+          <a:bodyPr rtlCol="0" anchor="ctr" wrap="square"/>
+          <a:lstStyle/>
+          <a:p>
+            <a:pPr algn="ctr"/>
+          </a:p>
+        </p:txBody>
+      </p:sp>
+      <p:sp>
+        <p:nvSpPr>
+          <p:cNvPr id="10" name="Oval 9"/>
+          <p:cNvSpPr/>
+          <p:nvPr/>
+        </p:nvSpPr>
+        <p:spPr>
+          <a:xfrm>
+            <a:off x="758952" y="2289048"/>
+            <a:ext cx="457200" cy="457200"/>
+          </a:xfrm>
+          <a:prstGeom prst="ellipse">
+            <a:avLst/>
+          </a:prstGeom>
+          <a:solidFill>
+            <a:srgbClr val="5B3FD6"/>
+          </a:solidFill>
+          <a:ln>
+            <a:noFill/>
+          </a:ln>
+          <a:effectLst/>
+        </p:spPr>
+        <p:style>
+          <a:lnRef idx="1">
+            <a:schemeClr val="accent1"/>
+          </a:lnRef>
+          <a:fillRef idx="3">
+            <a:schemeClr val="accent1"/>
+          </a:fillRef>
+          <a:effectRef idx="2">
+            <a:schemeClr val="accent1"/>
+          </a:effectRef>
+          <a:fontRef idx="minor">
+            <a:schemeClr val="lt1"/>
+          </a:fontRef>
+        </p:style>
+        <p:txBody>
+          <a:bodyPr rtlCol="0" anchor="ctr" wrap="square"/>
+          <a:lstStyle/>
+          <a:p>
+            <a:pPr algn="ctr"/>
+          </a:p>
+        </p:txBody>
+      </p:sp>
+      <p:pic>
+        <p:nvPicPr>
+          <p:cNvPr id="11" name="Picture 10" descr="message-square_028dbd132a0a.png"/>
+          <p:cNvPicPr>
+            <a:picLocks noChangeAspect="1"/>
+          </p:cNvPicPr>
+          <p:nvPr/>
+        </p:nvPicPr>
+        <p:blipFill>
+          <a:blip r:embed="rId4"/>
+          <a:stretch>
+            <a:fillRect/>
+          </a:stretch>
+        </p:blipFill>
+        <p:spPr>
+          <a:xfrm>
+            <a:off x="868680" y="2398776"/>
+            <a:ext cx="237744" cy="237744"/>
+          </a:xfrm>
+          <a:prstGeom prst="rect">
+            <a:avLst/>
+          </a:prstGeom>
+        </p:spPr>
+      </p:pic>
+      <p:sp>
+        <p:nvSpPr>
+          <p:cNvPr id="12" name="TextBox 11"/>
+          <p:cNvSpPr txBox="1"/>
+          <p:nvPr/>
+        </p:nvSpPr>
+        <p:spPr>
+          <a:xfrm>
+            <a:off x="1399031" y="2103120"/>
+            <a:ext cx="9987991" cy="160401"/>
+          </a:xfrm>
+          <a:prstGeom prst="rect">
+            <a:avLst/>
+          </a:prstGeom>
+          <a:noFill/>
+        </p:spPr>
+        <p:txBody>
+          <a:bodyPr wrap="square" anchor="t" lIns="0" rIns="0" tIns="0" bIns="0">
+            <a:spAutoFit/>
+          </a:bodyPr>
+          <a:lstStyle/>
+          <a:p>
+            <a:pPr algn="l"/>
+            <a:r>
+              <a:rPr sz="750" b="1" i="0" spc="250">
+                <a:solidFill>
+                  <a:srgbClr val="D9A7FF"/>
+                </a:solidFill>
+                <a:latin typeface="Calibri"/>
+              </a:rPr>
+              <a:t>THE CLIENT ASKS</a:t>
+            </a:r>
+          </a:p>
+        </p:txBody>
+      </p:sp>
+      <p:sp>
+        <p:nvSpPr>
+          <p:cNvPr id="13" name="TextBox 12"/>
+          <p:cNvSpPr txBox="1"/>
+          <p:nvPr/>
+        </p:nvSpPr>
+        <p:spPr>
+          <a:xfrm>
+            <a:off x="1399031" y="2322576"/>
+            <a:ext cx="9987991" cy="682752"/>
+          </a:xfrm>
+          <a:prstGeom prst="rect">
+            <a:avLst/>
+          </a:prstGeom>
+          <a:noFill/>
+        </p:spPr>
+        <p:txBody>
+          <a:bodyPr wrap="square" anchor="t" lIns="0" rIns="0" tIns="0" bIns="0">
+            <a:spAutoFit/>
+          </a:bodyPr>
+          <a:lstStyle/>
+          <a:p>
+            <a:r>
+              <a:rPr sz="1500" b="0" i="0">
+                <a:solidFill>
+                  <a:srgbClr val="FFFFFF"/>
+                </a:solidFill>
+                <a:latin typeface="Calibri"/>
+              </a:rPr>
+              <a:t>"We want one table with one row per customer, refreshed every Monday: how recently they bought, how often, how much, their segment, whether the monsoon sale reached them, and last week's flags."</a:t>
+            </a:r>
+          </a:p>
+        </p:txBody>
+      </p:sp>
+      <p:pic>
+        <p:nvPicPr>
+          <p:cNvPr id="14" name="mermaid diagram" descr="a8ecfae2913fb977.png"/>
+          <p:cNvPicPr>
+            <a:picLocks noChangeAspect="1"/>
+          </p:cNvPicPr>
+          <p:nvPr/>
+        </p:nvPicPr>
+        <p:blipFill>
+          <a:blip r:embed="rId6"/>
+          <a:stretch>
+            <a:fillRect/>
+          </a:stretch>
+        </p:blipFill>
+        <p:spPr>
+          <a:xfrm>
+            <a:off x="2102491" y="3243072"/>
+            <a:ext cx="7986712" cy="1128712"/>
+          </a:xfrm>
+          <a:prstGeom prst="rect">
+            <a:avLst/>
+          </a:prstGeom>
+        </p:spPr>
+      </p:pic>
+      <p:sp>
+        <p:nvSpPr>
+          <p:cNvPr id="15" name="Oval 14"/>
+          <p:cNvSpPr/>
+          <p:nvPr/>
+        </p:nvSpPr>
+        <p:spPr>
+          <a:xfrm>
+            <a:off x="530352" y="6492240"/>
+            <a:ext cx="64008" cy="64008"/>
+          </a:xfrm>
+          <a:prstGeom prst="ellipse">
+            <a:avLst/>
+          </a:prstGeom>
+          <a:solidFill>
+            <a:srgbClr val="CFC9EE"/>
+          </a:solidFill>
+          <a:ln>
+            <a:noFill/>
+          </a:ln>
+          <a:effectLst/>
+        </p:spPr>
+        <p:style>
+          <a:lnRef idx="1">
+            <a:schemeClr val="accent1"/>
+          </a:lnRef>
+          <a:fillRef idx="3">
+            <a:schemeClr val="accent1"/>
+          </a:fillRef>
+          <a:effectRef idx="2">
+            <a:schemeClr val="accent1"/>
+          </a:effectRef>
+          <a:fontRef idx="minor">
+            <a:schemeClr val="lt1"/>
+          </a:fontRef>
+        </p:style>
+        <p:txBody>
+          <a:bodyPr rtlCol="0" anchor="ctr" wrap="square"/>
+          <a:lstStyle/>
+          <a:p>
+            <a:pPr algn="ctr"/>
+          </a:p>
+        </p:txBody>
+      </p:sp>
+      <p:sp>
+        <p:nvSpPr>
+          <p:cNvPr id="16" name="TextBox 15"/>
+          <p:cNvSpPr txBox="1"/>
+          <p:nvPr/>
+        </p:nvSpPr>
+        <p:spPr>
+          <a:xfrm>
+            <a:off x="640080" y="6437376"/>
+            <a:ext cx="1378457" cy="152146"/>
+          </a:xfrm>
+          <a:prstGeom prst="rect">
+            <a:avLst/>
+          </a:prstGeom>
+          <a:noFill/>
+        </p:spPr>
+        <p:txBody>
+          <a:bodyPr wrap="square" anchor="t" lIns="0" rIns="0" tIns="0" bIns="0">
+            <a:spAutoFit/>
+          </a:bodyPr>
+          <a:lstStyle/>
+          <a:p>
+            <a:pPr algn="l"/>
+            <a:r>
+              <a:rPr sz="700" b="0" i="0">
+                <a:solidFill>
+                  <a:srgbClr val="6B6690"/>
+                </a:solidFill>
+                <a:latin typeface="Calibri"/>
+              </a:rPr>
+              <a:t>Who does Marketing call?</a:t>
+            </a:r>
+          </a:p>
+        </p:txBody>
+      </p:sp>
+      <p:sp>
+        <p:nvSpPr>
+          <p:cNvPr id="17" name="Oval 16"/>
+          <p:cNvSpPr/>
+          <p:nvPr/>
+        </p:nvSpPr>
+        <p:spPr>
+          <a:xfrm>
+            <a:off x="2109977" y="6492240"/>
+            <a:ext cx="64008" cy="64008"/>
+          </a:xfrm>
+          <a:prstGeom prst="ellipse">
+            <a:avLst/>
+          </a:prstGeom>
+          <a:solidFill>
+            <a:srgbClr val="CFC9EE"/>
+          </a:solidFill>
+          <a:ln>
+            <a:noFill/>
+          </a:ln>
+          <a:effectLst/>
+        </p:spPr>
+        <p:style>
+          <a:lnRef idx="1">
+            <a:schemeClr val="accent1"/>
+          </a:lnRef>
+          <a:fillRef idx="3">
+            <a:schemeClr val="accent1"/>
+          </a:fillRef>
+          <a:effectRef idx="2">
+            <a:schemeClr val="accent1"/>
+          </a:effectRef>
+          <a:fontRef idx="minor">
+            <a:schemeClr val="lt1"/>
+          </a:fontRef>
+        </p:style>
+        <p:txBody>
+          <a:bodyPr rtlCol="0" anchor="ctr" wrap="square"/>
+          <a:lstStyle/>
+          <a:p>
+            <a:pPr algn="ctr"/>
+          </a:p>
+        </p:txBody>
+      </p:sp>
+      <p:sp>
+        <p:nvSpPr>
+          <p:cNvPr id="18" name="TextBox 17"/>
+          <p:cNvSpPr txBox="1"/>
+          <p:nvPr/>
+        </p:nvSpPr>
+        <p:spPr>
+          <a:xfrm>
+            <a:off x="2219706" y="6437376"/>
+            <a:ext cx="1194435" cy="152146"/>
+          </a:xfrm>
+          <a:prstGeom prst="rect">
+            <a:avLst/>
+          </a:prstGeom>
+          <a:noFill/>
+        </p:spPr>
+        <p:txBody>
+          <a:bodyPr wrap="square" anchor="t" lIns="0" rIns="0" tIns="0" bIns="0">
+            <a:spAutoFit/>
+          </a:bodyPr>
+          <a:lstStyle/>
+          <a:p>
+            <a:pPr algn="l"/>
+            <a:r>
+              <a:rPr sz="700" b="0" i="0">
+                <a:solidFill>
+                  <a:srgbClr val="6B6690"/>
+                </a:solidFill>
+                <a:latin typeface="Calibri"/>
+              </a:rPr>
+              <a:t>Can you do it alone?</a:t>
+            </a:r>
+          </a:p>
+        </p:txBody>
+      </p:sp>
+      <p:sp>
+        <p:nvSpPr>
+          <p:cNvPr id="19" name="Oval 18"/>
+          <p:cNvSpPr/>
+          <p:nvPr/>
+        </p:nvSpPr>
+        <p:spPr>
+          <a:xfrm>
+            <a:off x="3505580" y="6492240"/>
+            <a:ext cx="64008" cy="64008"/>
+          </a:xfrm>
+          <a:prstGeom prst="ellipse">
+            <a:avLst/>
+          </a:prstGeom>
+          <a:solidFill>
+            <a:srgbClr val="5B3FD6"/>
+          </a:solidFill>
+          <a:ln>
+            <a:noFill/>
+          </a:ln>
+          <a:effectLst/>
+        </p:spPr>
+        <p:style>
+          <a:lnRef idx="1">
+            <a:schemeClr val="accent1"/>
+          </a:lnRef>
+          <a:fillRef idx="3">
+            <a:schemeClr val="accent1"/>
+          </a:fillRef>
+          <a:effectRef idx="2">
+            <a:schemeClr val="accent1"/>
+          </a:effectRef>
+          <a:fontRef idx="minor">
+            <a:schemeClr val="lt1"/>
+          </a:fontRef>
+        </p:style>
+        <p:txBody>
+          <a:bodyPr rtlCol="0" anchor="ctr" wrap="square"/>
+          <a:lstStyle/>
+          <a:p>
+            <a:pPr algn="ctr"/>
+          </a:p>
+        </p:txBody>
+      </p:sp>
+      <p:sp>
+        <p:nvSpPr>
+          <p:cNvPr id="20" name="TextBox 19"/>
+          <p:cNvSpPr txBox="1"/>
+          <p:nvPr/>
+        </p:nvSpPr>
+        <p:spPr>
+          <a:xfrm>
+            <a:off x="3615308" y="6437376"/>
+            <a:ext cx="1470469" cy="152146"/>
+          </a:xfrm>
+          <a:prstGeom prst="rect">
+            <a:avLst/>
+          </a:prstGeom>
+          <a:noFill/>
+        </p:spPr>
+        <p:txBody>
+          <a:bodyPr wrap="square" anchor="t" lIns="0" rIns="0" tIns="0" bIns="0">
+            <a:spAutoFit/>
+          </a:bodyPr>
+          <a:lstStyle/>
+          <a:p>
+            <a:pPr algn="l"/>
+            <a:r>
+              <a:rPr sz="700" b="1" i="0">
+                <a:solidFill>
+                  <a:srgbClr val="5B3FD6"/>
+                </a:solidFill>
+                <a:latin typeface="Calibri"/>
+              </a:rPr>
+              <a:t>What do we tell Marketing?</a:t>
+            </a:r>
+          </a:p>
+        </p:txBody>
+      </p:sp>
+      <p:sp>
+        <p:nvSpPr>
+          <p:cNvPr id="21" name="TextBox 20"/>
+          <p:cNvSpPr txBox="1"/>
+          <p:nvPr/>
+        </p:nvSpPr>
+        <p:spPr>
+          <a:xfrm>
+            <a:off x="10198303" y="6437376"/>
+            <a:ext cx="1463040" cy="160401"/>
+          </a:xfrm>
+          <a:prstGeom prst="rect">
+            <a:avLst/>
+          </a:prstGeom>
+          <a:noFill/>
+        </p:spPr>
+        <p:txBody>
+          <a:bodyPr wrap="square" anchor="t" lIns="0" rIns="0" tIns="0" bIns="0">
+            <a:spAutoFit/>
+          </a:bodyPr>
+          <a:lstStyle/>
+          <a:p>
+            <a:pPr algn="r"/>
+            <a:r>
+              <a:rPr sz="750" b="0" i="0">
+                <a:solidFill>
+                  <a:srgbClr val="6B6690"/>
+                </a:solidFill>
+                <a:latin typeface="Calibri"/>
+              </a:rPr>
+              <a:t>S26  ·  30 / 30</a:t>
             </a:r>
           </a:p>
         </p:txBody>
@@ -27147,7 +27969,7 @@
                 </a:solidFill>
                 <a:latin typeface="Calibri"/>
               </a:rPr>
-              <a:t>The member team rings the flagged members on the protect lists this week, and the head of Retail-Plus answers to his members for every call. A call that tells a loyal member his spend is falling when he was away costs his goodwill and maybe his renewal.</a:t>
+              <a:t>The member team rings the flagged members on the protect lists this week, and the head of Retail-Plus answers to the tier's members for every call. A call that tells a loyal member their spend is falling when they were away costs their goodwill and maybe their renewal.</a:t>
             </a:r>
           </a:p>
         </p:txBody>
@@ -28687,7 +29509,7 @@
                 </a:solidFill>
                 <a:latin typeface="Calibri"/>
               </a:rPr>
-              <a:t>S2  ·  4 / 29</a:t>
+              <a:t>S2  ·  4 / 30</a:t>
             </a:r>
           </a:p>
         </p:txBody>
@@ -29155,7 +29977,7 @@
                 </a:solidFill>
                 <a:latin typeface="Calibri"/>
               </a:rPr>
-              <a:t>Answers to his members for every call the member team makes.</a:t>
+              <a:t>Answers to the tier's members for every call the member team makes.</a:t>
             </a:r>
           </a:p>
         </p:txBody>
@@ -29615,7 +30437,7 @@
                 </a:solidFill>
                 <a:latin typeface="Calibri"/>
               </a:rPr>
-              <a:t>His goodwill, maybe his renewal, and a week of calls spent on false alarms.</a:t>
+              <a:t>Their goodwill, maybe their renewal, and a week of calls spent on false alarms.</a:t>
             </a:r>
           </a:p>
         </p:txBody>
@@ -29812,7 +30634,7 @@
                 </a:solidFill>
                 <a:latin typeface="Calibri"/>
               </a:rPr>
-              <a:t>"Is your flag wrong about him, and how many others?"</a:t>
+              <a:t>"Is your flag wrong about them, and how many others?"</a:t>
             </a:r>
           </a:p>
         </p:txBody>
@@ -30084,7 +30906,7 @@
                 </a:solidFill>
                 <a:latin typeface="Calibri"/>
               </a:rPr>
-              <a:t>S3  ·  5 / 29</a:t>
+              <a:t>S3  ·  5 / 30</a:t>
             </a:r>
           </a:p>
         </p:txBody>
@@ -30332,7 +31154,7 @@
       </p:sp>
       <p:pic>
         <p:nvPicPr>
-          <p:cNvPr id="9" name="mermaid diagram" descr="42125c35229b1109.png"/>
+          <p:cNvPr id="9" name="mermaid diagram" descr="85128bbef259f1ec.png"/>
           <p:cNvPicPr>
             <a:picLocks noChangeAspect="1"/>
           </p:cNvPicPr>
@@ -30346,8 +31168,8 @@
         </p:blipFill>
         <p:spPr>
           <a:xfrm>
-            <a:off x="854597" y="1682496"/>
-            <a:ext cx="4137834" cy="4517136"/>
+            <a:off x="3186733" y="1664208"/>
+            <a:ext cx="5818228" cy="3203447"/>
           </a:xfrm>
           <a:prstGeom prst="rect">
             <a:avLst/>
@@ -30362,8 +31184,8 @@
         </p:nvSpPr>
         <p:spPr>
           <a:xfrm>
-            <a:off x="5761917" y="1956816"/>
-            <a:ext cx="5899425" cy="1639824"/>
+            <a:off x="530352" y="4913376"/>
+            <a:ext cx="11130991" cy="1121664"/>
           </a:xfrm>
           <a:prstGeom prst="roundRect">
             <a:avLst>
@@ -30416,7 +31238,7 @@
         </p:nvSpPr>
         <p:spPr>
           <a:xfrm>
-            <a:off x="5990517" y="2548128"/>
+            <a:off x="758952" y="5245608"/>
             <a:ext cx="457200" cy="457200"/>
           </a:xfrm>
           <a:prstGeom prst="ellipse">
@@ -30468,7 +31290,7 @@
         </p:blipFill>
         <p:spPr>
           <a:xfrm>
-            <a:off x="6100245" y="2657856"/>
+            <a:off x="868680" y="5355336"/>
             <a:ext cx="237744" cy="237744"/>
           </a:xfrm>
           <a:prstGeom prst="rect">
@@ -30484,8 +31306,8 @@
         </p:nvSpPr>
         <p:spPr>
           <a:xfrm>
-            <a:off x="6630597" y="2103120"/>
-            <a:ext cx="4756425" cy="160401"/>
+            <a:off x="1399031" y="5059680"/>
+            <a:ext cx="9987991" cy="160401"/>
           </a:xfrm>
           <a:prstGeom prst="rect">
             <a:avLst/>
@@ -30519,8 +31341,8 @@
         </p:nvSpPr>
         <p:spPr>
           <a:xfrm>
-            <a:off x="6630597" y="2322576"/>
-            <a:ext cx="4756425" cy="1200912"/>
+            <a:off x="1399031" y="5279136"/>
+            <a:ext cx="9987991" cy="682752"/>
           </a:xfrm>
           <a:prstGeom prst="rect">
             <a:avLst/>
@@ -30812,7 +31634,7 @@
                 </a:solidFill>
                 <a:latin typeface="Calibri"/>
               </a:rPr>
-              <a:t>S4  ·  6 / 29</a:t>
+              <a:t>S4  ·  6 / 30</a:t>
             </a:r>
           </a:p>
         </p:txBody>
@@ -31940,7 +32762,7 @@
                 </a:solidFill>
                 <a:latin typeface="Calibri"/>
               </a:rPr>
-              <a:t>S5  ·  7 / 29</a:t>
+              <a:t>S5  ·  7 / 30</a:t>
             </a:r>
           </a:p>
         </p:txBody>
@@ -32188,7 +33010,7 @@
       </p:sp>
       <p:pic>
         <p:nvPicPr>
-          <p:cNvPr id="9" name="mermaid diagram" descr="9bd98ac1668d421c.png"/>
+          <p:cNvPr id="9" name="mermaid diagram" descr="054ebe97ce9d4699.png"/>
           <p:cNvPicPr>
             <a:picLocks noChangeAspect="1"/>
           </p:cNvPicPr>
@@ -32202,8 +33024,8 @@
         </p:blipFill>
         <p:spPr>
           <a:xfrm>
-            <a:off x="2395385" y="1956816"/>
-            <a:ext cx="7400925" cy="3043237"/>
+            <a:off x="3459803" y="1956816"/>
+            <a:ext cx="5272087" cy="2300287"/>
           </a:xfrm>
           <a:prstGeom prst="rect">
             <a:avLst/>
@@ -32477,7 +33299,7 @@
                 </a:solidFill>
                 <a:latin typeface="Calibri"/>
               </a:rPr>
-              <a:t>S6  ·  8 / 29</a:t>
+              <a:t>S6  ·  8 / 30</a:t>
             </a:r>
           </a:p>
         </p:txBody>
@@ -32725,7 +33547,7 @@
       </p:sp>
       <p:pic>
         <p:nvPicPr>
-          <p:cNvPr id="9" name="mermaid diagram" descr="8c7b1f5da3100c69.png"/>
+          <p:cNvPr id="9" name="mermaid diagram" descr="be445e52615d0647.png"/>
           <p:cNvPicPr>
             <a:picLocks noChangeAspect="1"/>
           </p:cNvPicPr>
@@ -32739,8 +33561,8 @@
         </p:blipFill>
         <p:spPr>
           <a:xfrm>
-            <a:off x="3762689" y="1664208"/>
-            <a:ext cx="4666315" cy="3250692"/>
+            <a:off x="3731266" y="1956816"/>
+            <a:ext cx="4729162" cy="2043112"/>
           </a:xfrm>
           <a:prstGeom prst="rect">
             <a:avLst/>
@@ -32755,7 +33577,7 @@
         </p:nvSpPr>
         <p:spPr>
           <a:xfrm>
-            <a:off x="530352" y="4960620"/>
+            <a:off x="530352" y="4146232"/>
             <a:ext cx="11130991" cy="1074420"/>
           </a:xfrm>
           <a:prstGeom prst="roundRect">
@@ -32803,7 +33625,7 @@
         </p:nvSpPr>
         <p:spPr>
           <a:xfrm>
-            <a:off x="676656" y="5088636"/>
+            <a:off x="676656" y="4274248"/>
             <a:ext cx="45720" cy="818388"/>
           </a:xfrm>
           <a:prstGeom prst="roundRect">
@@ -32849,7 +33671,7 @@
         </p:nvSpPr>
         <p:spPr>
           <a:xfrm>
-            <a:off x="877824" y="5079492"/>
+            <a:off x="877824" y="4265104"/>
             <a:ext cx="10564063" cy="891540"/>
           </a:xfrm>
           <a:prstGeom prst="rect">
@@ -33151,7 +33973,7 @@
                 </a:solidFill>
                 <a:latin typeface="Calibri"/>
               </a:rPr>
-              <a:t>S7  ·  9 / 29</a:t>
+              <a:t>S7  ·  9 / 30</a:t>
             </a:r>
           </a:p>
         </p:txBody>

</xml_diff>

<commit_message>
W02 D3 decks: the topics slide follows the ask, gives nothing away, and the minutes add up
The morning's topics slide moves to S6a, after the room's own GROUP BY finding,
and loses the caption that answered S4 and named chapter 5's check; Tuesday's
box is the joined, validated table feeding the window. S32a and S74a run one
minute each, S6 and S75 give a minute, and the afternoon's S1a shares S1's. S55a
says the flag reads the member's two rows before September; S74a asks for a
column no two rows share after any business key and says why peers share a
figure; S32a's check runs as printed. Both decks rebuilt on mermaid-cli 11.17.0,
the version setup.sh pins.

Co-Authored-By: Claude Opus 5.5 <noreply@anthropic.com>
Claude-Session: https://claude.ai/code/session_01AFKXvtsXr8QEoPG5vJisyZ
</commit_message>
<xml_diff>
--- a/content/W02/D3/slides/C2_W02_D03_half2_STUDENT.pptx
+++ b/content/W02/D3/slides/C2_W02_D03_half2_STUDENT.pptx
@@ -1372,17 +1372,17 @@
           <a:lstStyle/>
           <a:p>
             <a:r>
-              <a:t>LIVE, 1 minute. Read the five answers as one story. Q2 is July to September 2026; revenue is</a:t>
-            </a:r>
-          </a:p>
-          <a:p>
-            <a:r>
-              <a:t>booked revenue, every order at its amount whatever its status, Rs 9,84,00,000 for the quarter.</a:t>
-            </a:r>
-          </a:p>
-          <a:p>
-            <a:r>
-              <a:t>Then the day's six topics.</a:t>
+              <a:t>LIVE, 1 minute, which S1a shares. Read the five answers as one story. Q2 is July to September</a:t>
+            </a:r>
+          </a:p>
+          <a:p>
+            <a:r>
+              <a:t>2026; revenue is booked revenue, every order at its amount whatever its status, Rs 9,84,00,000</a:t>
+            </a:r>
+          </a:p>
+          <a:p>
+            <a:r>
+              <a:t>for the quarter. Then the day's six topics.</a:t>
             </a:r>
           </a:p>
         </p:txBody>
@@ -2327,17 +2327,22 @@
           <a:lstStyle/>
           <a:p>
             <a:r>
-              <a:t>LIVE, under a minute. These are the six topics the morning opened on. Point at the fourth row:</a:t>
-            </a:r>
-          </a:p>
-          <a:p>
-            <a:r>
-              <a:t>chapter 6 finishes the month-on-month comparison per customer by checking LAG's months against the</a:t>
-            </a:r>
-          </a:p>
-          <a:p>
-            <a:r>
-              <a:t>calendar, and the escalated case then uses all six. Then chapter 6.</a:t>
+              <a:t>LIVE, inside S1's minute. These are the six topics the morning listed before chapter 1. Point at</a:t>
+            </a:r>
+          </a:p>
+          <a:p>
+            <a:r>
+              <a:t>the fourth row: chapter 6 finishes the month-on-month comparison per customer by checking LAG's</a:t>
+            </a:r>
+          </a:p>
+          <a:p>
+            <a:r>
+              <a:t>months against the calendar, and the escalated case then puts the topics to work together. Then</a:t>
+            </a:r>
+          </a:p>
+          <a:p>
+            <a:r>
+              <a:t>chapter 6.</a:t>
             </a:r>
           </a:p>
         </p:txBody>
@@ -6818,7 +6823,7 @@
       </p:sp>
       <p:pic>
         <p:nvPicPr>
-          <p:cNvPr id="9" name="mermaid diagram" descr="8c7b1f5da3100c69.png"/>
+          <p:cNvPr id="9" name="mermaid diagram" descr="be445e52615d0647.png"/>
           <p:cNvPicPr>
             <a:picLocks noChangeAspect="1"/>
           </p:cNvPicPr>
@@ -6832,8 +6837,8 @@
         </p:blipFill>
         <p:spPr>
           <a:xfrm>
-            <a:off x="3762689" y="1664208"/>
-            <a:ext cx="4666315" cy="3250692"/>
+            <a:off x="3731266" y="1956816"/>
+            <a:ext cx="4729162" cy="2043112"/>
           </a:xfrm>
           <a:prstGeom prst="rect">
             <a:avLst/>
@@ -6848,7 +6853,7 @@
         </p:nvSpPr>
         <p:spPr>
           <a:xfrm>
-            <a:off x="530352" y="4960620"/>
+            <a:off x="530352" y="4146232"/>
             <a:ext cx="11130991" cy="1074420"/>
           </a:xfrm>
           <a:prstGeom prst="roundRect">
@@ -6896,7 +6901,7 @@
         </p:nvSpPr>
         <p:spPr>
           <a:xfrm>
-            <a:off x="676656" y="5088636"/>
+            <a:off x="676656" y="4274248"/>
             <a:ext cx="45720" cy="818388"/>
           </a:xfrm>
           <a:prstGeom prst="roundRect">
@@ -6942,7 +6947,7 @@
         </p:nvSpPr>
         <p:spPr>
           <a:xfrm>
-            <a:off x="877824" y="5079492"/>
+            <a:off x="877824" y="4265104"/>
             <a:ext cx="10564063" cy="891540"/>
           </a:xfrm>
           <a:prstGeom prst="rect">
@@ -9433,7 +9438,7 @@
       </p:sp>
       <p:pic>
         <p:nvPicPr>
-          <p:cNvPr id="9" name="mermaid diagram" descr="d7920b8c8aeac347.png"/>
+          <p:cNvPr id="9" name="mermaid diagram" descr="cae16322f66e6210.png"/>
           <p:cNvPicPr>
             <a:picLocks noChangeAspect="1"/>
           </p:cNvPicPr>
@@ -9447,8 +9452,8 @@
         </p:blipFill>
         <p:spPr>
           <a:xfrm>
-            <a:off x="1409547" y="1956816"/>
-            <a:ext cx="9372600" cy="2000250"/>
+            <a:off x="3352647" y="1956816"/>
+            <a:ext cx="5486400" cy="1557337"/>
           </a:xfrm>
           <a:prstGeom prst="rect">
             <a:avLst/>
@@ -9463,7 +9468,7 @@
         </p:nvSpPr>
         <p:spPr>
           <a:xfrm>
-            <a:off x="530352" y="4103370"/>
+            <a:off x="530352" y="3660457"/>
             <a:ext cx="11130991" cy="807720"/>
           </a:xfrm>
           <a:prstGeom prst="roundRect">
@@ -9511,7 +9516,7 @@
         </p:nvSpPr>
         <p:spPr>
           <a:xfrm>
-            <a:off x="676656" y="4231385"/>
+            <a:off x="676656" y="3788473"/>
             <a:ext cx="45720" cy="551688"/>
           </a:xfrm>
           <a:prstGeom prst="roundRect">
@@ -9557,7 +9562,7 @@
         </p:nvSpPr>
         <p:spPr>
           <a:xfrm>
-            <a:off x="877824" y="4222242"/>
+            <a:off x="877824" y="3779329"/>
             <a:ext cx="10564063" cy="624840"/>
           </a:xfrm>
           <a:prstGeom prst="rect">
@@ -11109,7 +11114,7 @@
       </p:sp>
       <p:pic>
         <p:nvPicPr>
-          <p:cNvPr id="9" name="mermaid diagram" descr="99986eef7fcc0090.png"/>
+          <p:cNvPr id="9" name="mermaid diagram" descr="0880f8b546cd4842.png"/>
           <p:cNvPicPr>
             <a:picLocks noChangeAspect="1"/>
           </p:cNvPicPr>
@@ -11123,8 +11128,8 @@
         </p:blipFill>
         <p:spPr>
           <a:xfrm>
-            <a:off x="3858637" y="1664208"/>
-            <a:ext cx="4474420" cy="3517392"/>
+            <a:off x="3016891" y="1956816"/>
+            <a:ext cx="6157912" cy="2300287"/>
           </a:xfrm>
           <a:prstGeom prst="rect">
             <a:avLst/>
@@ -11139,7 +11144,7 @@
         </p:nvSpPr>
         <p:spPr>
           <a:xfrm>
-            <a:off x="530352" y="5227320"/>
+            <a:off x="530352" y="4403407"/>
             <a:ext cx="11130991" cy="807720"/>
           </a:xfrm>
           <a:prstGeom prst="roundRect">
@@ -11187,7 +11192,7 @@
         </p:nvSpPr>
         <p:spPr>
           <a:xfrm>
-            <a:off x="676656" y="5355336"/>
+            <a:off x="676656" y="4531423"/>
             <a:ext cx="45720" cy="551688"/>
           </a:xfrm>
           <a:prstGeom prst="roundRect">
@@ -11233,7 +11238,7 @@
         </p:nvSpPr>
         <p:spPr>
           <a:xfrm>
-            <a:off x="877824" y="5346192"/>
+            <a:off x="877824" y="4522279"/>
             <a:ext cx="10564063" cy="624840"/>
           </a:xfrm>
           <a:prstGeom prst="rect">
@@ -21801,7 +21806,7 @@
       </p:sp>
       <p:pic>
         <p:nvPicPr>
-          <p:cNvPr id="9" name="mermaid diagram" descr="a69f3fbfe7bc78a4.png"/>
+          <p:cNvPr id="9" name="mermaid diagram" descr="11811dd0a6b07bd4.png"/>
           <p:cNvPicPr>
             <a:picLocks noChangeAspect="1"/>
           </p:cNvPicPr>
@@ -21815,8 +21820,8 @@
         </p:blipFill>
         <p:spPr>
           <a:xfrm>
-            <a:off x="530352" y="1896466"/>
-            <a:ext cx="11130991" cy="1105204"/>
+            <a:off x="530352" y="1956816"/>
+            <a:ext cx="11130991" cy="822589"/>
           </a:xfrm>
           <a:prstGeom prst="rect">
             <a:avLst/>
@@ -21831,7 +21836,7 @@
         </p:nvSpPr>
         <p:spPr>
           <a:xfrm>
-            <a:off x="530352" y="3111398"/>
+            <a:off x="530352" y="2889133"/>
             <a:ext cx="502920" cy="333756"/>
           </a:xfrm>
           <a:prstGeom prst="rect">
@@ -21866,7 +21871,7 @@
         </p:nvSpPr>
         <p:spPr>
           <a:xfrm>
-            <a:off x="1097280" y="3147974"/>
+            <a:off x="1097280" y="2925709"/>
             <a:ext cx="10564063" cy="368808"/>
           </a:xfrm>
           <a:prstGeom prst="rect">
@@ -21900,7 +21905,7 @@
         </p:nvSpPr>
         <p:spPr>
           <a:xfrm>
-            <a:off x="530352" y="3553358"/>
+            <a:off x="530352" y="3331093"/>
             <a:ext cx="502920" cy="333756"/>
           </a:xfrm>
           <a:prstGeom prst="rect">
@@ -21935,7 +21940,7 @@
         </p:nvSpPr>
         <p:spPr>
           <a:xfrm>
-            <a:off x="1097280" y="3589934"/>
+            <a:off x="1097280" y="3367669"/>
             <a:ext cx="10564063" cy="368808"/>
           </a:xfrm>
           <a:prstGeom prst="rect">
@@ -21969,7 +21974,7 @@
         </p:nvSpPr>
         <p:spPr>
           <a:xfrm>
-            <a:off x="530352" y="3995318"/>
+            <a:off x="530352" y="3773053"/>
             <a:ext cx="502920" cy="333756"/>
           </a:xfrm>
           <a:prstGeom prst="rect">
@@ -22004,7 +22009,7 @@
         </p:nvSpPr>
         <p:spPr>
           <a:xfrm>
-            <a:off x="1097280" y="4031894"/>
+            <a:off x="1097280" y="3809629"/>
             <a:ext cx="10564063" cy="627888"/>
           </a:xfrm>
           <a:prstGeom prst="rect">
@@ -22038,7 +22043,7 @@
         </p:nvSpPr>
         <p:spPr>
           <a:xfrm>
-            <a:off x="530352" y="4696358"/>
+            <a:off x="530352" y="4474093"/>
             <a:ext cx="502920" cy="333756"/>
           </a:xfrm>
           <a:prstGeom prst="rect">
@@ -22073,7 +22078,7 @@
         </p:nvSpPr>
         <p:spPr>
           <a:xfrm>
-            <a:off x="1097280" y="4732934"/>
+            <a:off x="1097280" y="4510669"/>
             <a:ext cx="10564063" cy="368808"/>
           </a:xfrm>
           <a:prstGeom prst="rect">
@@ -22107,7 +22112,7 @@
         </p:nvSpPr>
         <p:spPr>
           <a:xfrm>
-            <a:off x="530352" y="5138318"/>
+            <a:off x="530352" y="4916053"/>
             <a:ext cx="502920" cy="333756"/>
           </a:xfrm>
           <a:prstGeom prst="rect">
@@ -22142,7 +22147,7 @@
         </p:nvSpPr>
         <p:spPr>
           <a:xfrm>
-            <a:off x="1097280" y="5174894"/>
+            <a:off x="1097280" y="4952629"/>
             <a:ext cx="10564063" cy="368808"/>
           </a:xfrm>
           <a:prstGeom prst="rect">
@@ -22176,7 +22181,7 @@
         </p:nvSpPr>
         <p:spPr>
           <a:xfrm>
-            <a:off x="530352" y="5580278"/>
+            <a:off x="530352" y="5358013"/>
             <a:ext cx="502920" cy="333756"/>
           </a:xfrm>
           <a:prstGeom prst="rect">
@@ -22211,7 +22216,7 @@
         </p:nvSpPr>
         <p:spPr>
           <a:xfrm>
-            <a:off x="1097280" y="5616854"/>
+            <a:off x="1097280" y="5394589"/>
             <a:ext cx="10564063" cy="368808"/>
           </a:xfrm>
           <a:prstGeom prst="rect">
@@ -25890,7 +25895,7 @@
       </p:sp>
       <p:pic>
         <p:nvPicPr>
-          <p:cNvPr id="15" name="mermaid diagram" descr="74b5f738e2ac4f9c.png"/>
+          <p:cNvPr id="15" name="mermaid diagram" descr="f626be52d68ee89f.png"/>
           <p:cNvPicPr>
             <a:picLocks noChangeAspect="1"/>
           </p:cNvPicPr>
@@ -25904,8 +25909,8 @@
         </p:blipFill>
         <p:spPr>
           <a:xfrm>
-            <a:off x="780897" y="3502152"/>
-            <a:ext cx="10629900" cy="1600200"/>
+            <a:off x="530352" y="3502152"/>
+            <a:ext cx="11130991" cy="858395"/>
           </a:xfrm>
           <a:prstGeom prst="rect">
             <a:avLst/>
@@ -26427,7 +26432,7 @@
       </p:sp>
       <p:pic>
         <p:nvPicPr>
-          <p:cNvPr id="9" name="mermaid diagram" descr="e379156194868999.png"/>
+          <p:cNvPr id="9" name="mermaid diagram" descr="8c9146e02051b291.png"/>
           <p:cNvPicPr>
             <a:picLocks noChangeAspect="1"/>
           </p:cNvPicPr>
@@ -26441,8 +26446,8 @@
         </p:blipFill>
         <p:spPr>
           <a:xfrm>
-            <a:off x="638013" y="1682496"/>
-            <a:ext cx="4571003" cy="4517136"/>
+            <a:off x="530352" y="2620005"/>
+            <a:ext cx="4786326" cy="2642116"/>
           </a:xfrm>
           <a:prstGeom prst="rect">
             <a:avLst/>
@@ -26458,8 +26463,8 @@
           <p:nvPr/>
         </p:nvGraphicFramePr>
         <p:xfrm>
-          <a:off x="5761917" y="1818640"/>
-          <a:ext cx="5899424" cy="2663952"/>
+          <a:off x="5761917" y="1938528"/>
+          <a:ext cx="5899423" cy="4005072"/>
         </p:xfrm>
         <a:graphic>
           <a:graphicData uri="http://schemas.openxmlformats.org/drawingml/2006/table">
@@ -26468,18 +26473,18 @@
                 <a:tableStyleId>{2D5ABB26-0587-4C30-8999-92F81FD0307C}</a:tableStyleId>
               </a:tblPr>
               <a:tblGrid>
-                <a:gridCol w="2369139"/>
-                <a:gridCol w="1949896"/>
-                <a:gridCol w="1580389"/>
+                <a:gridCol w="2275480"/>
+                <a:gridCol w="2177011"/>
+                <a:gridCol w="1446932"/>
               </a:tblGrid>
-              <a:tr h="310896">
+              <a:tr h="542544">
                 <a:tc>
                   <a:txBody>
                     <a:bodyPr/>
                     <a:lstStyle/>
                     <a:p>
                       <a:r>
-                        <a:rPr sz="1050" b="1" i="0">
+                        <a:rPr sz="1250" b="1" i="0">
                           <a:solidFill>
                             <a:srgbClr val="FFFFFF"/>
                           </a:solidFill>
@@ -26501,7 +26506,7 @@
                     <a:lstStyle/>
                     <a:p>
                       <a:r>
-                        <a:rPr sz="1050" b="1" i="0">
+                        <a:rPr sz="1250" b="1" i="0">
                           <a:solidFill>
                             <a:srgbClr val="FFFFFF"/>
                           </a:solidFill>
@@ -26523,7 +26528,7 @@
                     <a:lstStyle/>
                     <a:p>
                       <a:r>
-                        <a:rPr sz="1050" b="1" i="0">
+                        <a:rPr sz="1250" b="1" i="0">
                           <a:solidFill>
                             <a:srgbClr val="FFFFFF"/>
                           </a:solidFill>
@@ -26540,14 +26545,14 @@
                   </a:tcPr>
                 </a:tc>
               </a:tr>
-              <a:tr h="473456">
+              <a:tr h="749808">
                 <a:tc>
                   <a:txBody>
                     <a:bodyPr/>
                     <a:lstStyle/>
                     <a:p>
                       <a:r>
-                        <a:rPr sz="1000" b="0" i="0">
+                        <a:rPr sz="1200" b="0" i="0">
                           <a:solidFill>
                             <a:srgbClr val="1A1440"/>
                           </a:solidFill>
@@ -26569,7 +26574,7 @@
                     <a:lstStyle/>
                     <a:p>
                       <a:r>
-                        <a:rPr sz="1000" b="0" i="0">
+                        <a:rPr sz="1200" b="0" i="0">
                           <a:solidFill>
                             <a:srgbClr val="1A1440"/>
                           </a:solidFill>
@@ -26591,7 +26596,7 @@
                     <a:lstStyle/>
                     <a:p>
                       <a:r>
-                        <a:rPr sz="1000" b="0" i="0">
+                        <a:rPr sz="1200" b="0" i="0">
                           <a:solidFill>
                             <a:srgbClr val="1A1440"/>
                           </a:solidFill>
@@ -26608,14 +26613,14 @@
                   </a:tcPr>
                 </a:tc>
               </a:tr>
-              <a:tr h="473456">
+              <a:tr h="542544">
                 <a:tc>
                   <a:txBody>
                     <a:bodyPr/>
                     <a:lstStyle/>
                     <a:p>
                       <a:r>
-                        <a:rPr sz="1000" b="0" i="0">
+                        <a:rPr sz="1200" b="0" i="0">
                           <a:solidFill>
                             <a:srgbClr val="1A1440"/>
                           </a:solidFill>
@@ -26637,7 +26642,7 @@
                     <a:lstStyle/>
                     <a:p>
                       <a:r>
-                        <a:rPr sz="1000" b="0" i="0">
+                        <a:rPr sz="1200" b="0" i="0">
                           <a:solidFill>
                             <a:srgbClr val="1A1440"/>
                           </a:solidFill>
@@ -26659,7 +26664,7 @@
                     <a:lstStyle/>
                     <a:p>
                       <a:r>
-                        <a:rPr sz="1000" b="0" i="0">
+                        <a:rPr sz="1200" b="0" i="0">
                           <a:solidFill>
                             <a:srgbClr val="1A1440"/>
                           </a:solidFill>
@@ -26676,14 +26681,14 @@
                   </a:tcPr>
                 </a:tc>
               </a:tr>
-              <a:tr h="310896">
+              <a:tr h="542544">
                 <a:tc>
                   <a:txBody>
                     <a:bodyPr/>
                     <a:lstStyle/>
                     <a:p>
                       <a:r>
-                        <a:rPr sz="1000" b="0" i="0">
+                        <a:rPr sz="1200" b="0" i="0">
                           <a:solidFill>
                             <a:srgbClr val="1A1440"/>
                           </a:solidFill>
@@ -26705,7 +26710,7 @@
                     <a:lstStyle/>
                     <a:p>
                       <a:r>
-                        <a:rPr sz="1000" b="0" i="0">
+                        <a:rPr sz="1200" b="0" i="0">
                           <a:solidFill>
                             <a:srgbClr val="1A1440"/>
                           </a:solidFill>
@@ -26727,13 +26732,13 @@
                     <a:lstStyle/>
                     <a:p>
                       <a:r>
-                        <a:rPr sz="1000" b="0" i="0">
+                        <a:rPr sz="1200" b="0" i="0">
                           <a:solidFill>
                             <a:srgbClr val="1A1440"/>
                           </a:solidFill>
                           <a:latin typeface="Calibri"/>
                         </a:rPr>
-                        <a:t>the same 30</a:t>
+                        <a:t>within chapter 2's 30</a:t>
                       </a:r>
                     </a:p>
                   </a:txBody>
@@ -26744,14 +26749,14 @@
                   </a:tcPr>
                 </a:tc>
               </a:tr>
-              <a:tr h="473456">
+              <a:tr h="542544">
                 <a:tc>
                   <a:txBody>
                     <a:bodyPr/>
                     <a:lstStyle/>
                     <a:p>
                       <a:r>
-                        <a:rPr sz="1000" b="0" i="0">
+                        <a:rPr sz="1200" b="0" i="0">
                           <a:solidFill>
                             <a:srgbClr val="1A1440"/>
                           </a:solidFill>
@@ -26773,13 +26778,13 @@
                     <a:lstStyle/>
                     <a:p>
                       <a:r>
-                        <a:rPr sz="1000" b="0" i="0">
+                        <a:rPr sz="1200" b="0" i="0">
                           <a:solidFill>
                             <a:srgbClr val="1A1440"/>
                           </a:solidFill>
                           <a:latin typeface="Calibri"/>
                         </a:rPr>
-                        <a:t>4, and 6 on the calendar</a:t>
+                        <a:t>4, then 6 against calendar months</a:t>
                       </a:r>
                     </a:p>
                   </a:txBody>
@@ -26795,7 +26800,7 @@
                     <a:lstStyle/>
                     <a:p>
                       <a:r>
-                        <a:rPr sz="1000" b="0" i="0">
+                        <a:rPr sz="1200" b="0" i="0">
                           <a:solidFill>
                             <a:srgbClr val="1A1440"/>
                           </a:solidFill>
@@ -26812,14 +26817,14 @@
                   </a:tcPr>
                 </a:tc>
               </a:tr>
-              <a:tr h="310896">
+              <a:tr h="542544">
                 <a:tc>
                   <a:txBody>
                     <a:bodyPr/>
                     <a:lstStyle/>
                     <a:p>
                       <a:r>
-                        <a:rPr sz="1000" b="0" i="0">
+                        <a:rPr sz="1200" b="0" i="0">
                           <a:solidFill>
                             <a:srgbClr val="1A1440"/>
                           </a:solidFill>
@@ -26841,7 +26846,7 @@
                     <a:lstStyle/>
                     <a:p>
                       <a:r>
-                        <a:rPr sz="1000" b="0" i="0">
+                        <a:rPr sz="1200" b="0" i="0">
                           <a:solidFill>
                             <a:srgbClr val="1A1440"/>
                           </a:solidFill>
@@ -26863,7 +26868,7 @@
                     <a:lstStyle/>
                     <a:p>
                       <a:r>
-                        <a:rPr sz="1000" b="0" i="0">
+                        <a:rPr sz="1200" b="0" i="0">
                           <a:solidFill>
                             <a:srgbClr val="1A1440"/>
                           </a:solidFill>
@@ -26880,14 +26885,14 @@
                   </a:tcPr>
                 </a:tc>
               </a:tr>
-              <a:tr h="310896">
+              <a:tr h="542544">
                 <a:tc>
                   <a:txBody>
                     <a:bodyPr/>
                     <a:lstStyle/>
                     <a:p>
                       <a:r>
-                        <a:rPr sz="1000" b="0" i="0">
+                        <a:rPr sz="1200" b="0" i="0">
                           <a:solidFill>
                             <a:srgbClr val="1A1440"/>
                           </a:solidFill>
@@ -26909,7 +26914,7 @@
                     <a:lstStyle/>
                     <a:p>
                       <a:r>
-                        <a:rPr sz="1000" b="0" i="0">
+                        <a:rPr sz="1200" b="0" i="0">
                           <a:solidFill>
                             <a:srgbClr val="1A1440"/>
                           </a:solidFill>
@@ -26931,13 +26936,13 @@
                     <a:lstStyle/>
                     <a:p>
                       <a:r>
-                        <a:rPr sz="1000" b="0" i="0">
+                        <a:rPr sz="1200" b="0" i="0">
                           <a:solidFill>
                             <a:srgbClr val="1A1440"/>
                           </a:solidFill>
                           <a:latin typeface="Calibri"/>
                         </a:rPr>
-                        <a:t>4 of chapter 2's 30</a:t>
+                        <a:t>3 of chapter 2's 30</a:t>
                       </a:r>
                     </a:p>
                   </a:txBody>
@@ -26954,46 +26959,7 @@
       </p:graphicFrame>
       <p:sp>
         <p:nvSpPr>
-          <p:cNvPr id="11" name="TextBox 10"/>
-          <p:cNvSpPr txBox="1"/>
-          <p:nvPr/>
-        </p:nvSpPr>
-        <p:spPr>
-          <a:xfrm>
-            <a:off x="5761917" y="4738624"/>
-            <a:ext cx="5899425" cy="1324864"/>
-          </a:xfrm>
-          <a:prstGeom prst="rect">
-            <a:avLst/>
-          </a:prstGeom>
-          <a:noFill/>
-        </p:spPr>
-        <p:txBody>
-          <a:bodyPr wrap="square" anchor="t" lIns="0" rIns="0" tIns="0" bIns="0">
-            <a:spAutoFit/>
-          </a:bodyPr>
-          <a:lstStyle/>
-          <a:p>
-            <a:pPr>
-              <a:spcAft>
-                <a:spcPts val="800"/>
-              </a:spcAft>
-            </a:pPr>
-            <a:r>
-              <a:rPr sz="1600" b="0" i="0">
-                <a:solidFill>
-                  <a:srgbClr val="1A1440"/>
-                </a:solidFill>
-                <a:latin typeface="Calibri"/>
-              </a:rPr>
-              <a:t>Monday's GROUP BY collapses the rows a window keeps, and WHERE runs before any window, so a filter on the place waits for a CTE; Tuesday's join check closes chapter 5's running total on the quarter.</a:t>
-            </a:r>
-          </a:p>
-        </p:txBody>
-      </p:sp>
-      <p:sp>
-        <p:nvSpPr>
-          <p:cNvPr id="12" name="Oval 11"/>
+          <p:cNvPr id="11" name="Oval 10"/>
           <p:cNvSpPr/>
           <p:nvPr/>
         </p:nvSpPr>
@@ -27037,7 +27003,7 @@
       </p:sp>
       <p:sp>
         <p:nvSpPr>
-          <p:cNvPr id="13" name="TextBox 12"/>
+          <p:cNvPr id="12" name="TextBox 11"/>
           <p:cNvSpPr txBox="1"/>
           <p:nvPr/>
         </p:nvSpPr>
@@ -27072,7 +27038,7 @@
       </p:sp>
       <p:sp>
         <p:nvSpPr>
-          <p:cNvPr id="14" name="Oval 13"/>
+          <p:cNvPr id="13" name="Oval 12"/>
           <p:cNvSpPr/>
           <p:nvPr/>
         </p:nvSpPr>
@@ -27116,7 +27082,7 @@
       </p:sp>
       <p:sp>
         <p:nvSpPr>
-          <p:cNvPr id="15" name="TextBox 14"/>
+          <p:cNvPr id="14" name="TextBox 13"/>
           <p:cNvSpPr txBox="1"/>
           <p:nvPr/>
         </p:nvSpPr>
@@ -27151,7 +27117,7 @@
       </p:sp>
       <p:sp>
         <p:nvSpPr>
-          <p:cNvPr id="16" name="Oval 15"/>
+          <p:cNvPr id="15" name="Oval 14"/>
           <p:cNvSpPr/>
           <p:nvPr/>
         </p:nvSpPr>
@@ -27195,7 +27161,7 @@
       </p:sp>
       <p:sp>
         <p:nvSpPr>
-          <p:cNvPr id="17" name="TextBox 16"/>
+          <p:cNvPr id="16" name="TextBox 15"/>
           <p:cNvSpPr txBox="1"/>
           <p:nvPr/>
         </p:nvSpPr>
@@ -27230,7 +27196,7 @@
       </p:sp>
       <p:sp>
         <p:nvSpPr>
-          <p:cNvPr id="18" name="TextBox 17"/>
+          <p:cNvPr id="17" name="TextBox 16"/>
           <p:cNvSpPr txBox="1"/>
           <p:nvPr/>
         </p:nvSpPr>
@@ -28774,7 +28740,7 @@
       </p:sp>
       <p:pic>
         <p:nvPicPr>
-          <p:cNvPr id="14" name="mermaid diagram" descr="7c7d2ba252e30238.png"/>
+          <p:cNvPr id="14" name="mermaid diagram" descr="a8ecfae2913fb977.png"/>
           <p:cNvPicPr>
             <a:picLocks noChangeAspect="1"/>
           </p:cNvPicPr>
@@ -28788,8 +28754,8 @@
         </p:blipFill>
         <p:spPr>
           <a:xfrm>
-            <a:off x="2152497" y="3243072"/>
-            <a:ext cx="7886700" cy="1857375"/>
+            <a:off x="2102491" y="3243072"/>
+            <a:ext cx="7986712" cy="1128712"/>
           </a:xfrm>
           <a:prstGeom prst="rect">
             <a:avLst/>
@@ -33172,7 +33138,7 @@
       </p:sp>
       <p:pic>
         <p:nvPicPr>
-          <p:cNvPr id="9" name="mermaid diagram" descr="42125c35229b1109.png"/>
+          <p:cNvPr id="9" name="mermaid diagram" descr="85128bbef259f1ec.png"/>
           <p:cNvPicPr>
             <a:picLocks noChangeAspect="1"/>
           </p:cNvPicPr>
@@ -33186,8 +33152,8 @@
         </p:blipFill>
         <p:spPr>
           <a:xfrm>
-            <a:off x="854597" y="1682496"/>
-            <a:ext cx="4137834" cy="4517136"/>
+            <a:off x="3186733" y="1664208"/>
+            <a:ext cx="5818228" cy="3203447"/>
           </a:xfrm>
           <a:prstGeom prst="rect">
             <a:avLst/>
@@ -33202,8 +33168,8 @@
         </p:nvSpPr>
         <p:spPr>
           <a:xfrm>
-            <a:off x="5761917" y="1956816"/>
-            <a:ext cx="5899425" cy="1639824"/>
+            <a:off x="530352" y="4913376"/>
+            <a:ext cx="11130991" cy="1121664"/>
           </a:xfrm>
           <a:prstGeom prst="roundRect">
             <a:avLst>
@@ -33256,7 +33222,7 @@
         </p:nvSpPr>
         <p:spPr>
           <a:xfrm>
-            <a:off x="5990517" y="2548128"/>
+            <a:off x="758952" y="5245608"/>
             <a:ext cx="457200" cy="457200"/>
           </a:xfrm>
           <a:prstGeom prst="ellipse">
@@ -33308,7 +33274,7 @@
         </p:blipFill>
         <p:spPr>
           <a:xfrm>
-            <a:off x="6100245" y="2657856"/>
+            <a:off x="868680" y="5355336"/>
             <a:ext cx="237744" cy="237744"/>
           </a:xfrm>
           <a:prstGeom prst="rect">
@@ -33324,8 +33290,8 @@
         </p:nvSpPr>
         <p:spPr>
           <a:xfrm>
-            <a:off x="6630597" y="2103120"/>
-            <a:ext cx="4756425" cy="160401"/>
+            <a:off x="1399031" y="5059680"/>
+            <a:ext cx="9987991" cy="160401"/>
           </a:xfrm>
           <a:prstGeom prst="rect">
             <a:avLst/>
@@ -33359,8 +33325,8 @@
         </p:nvSpPr>
         <p:spPr>
           <a:xfrm>
-            <a:off x="6630597" y="2322576"/>
-            <a:ext cx="4756425" cy="1200912"/>
+            <a:off x="1399031" y="5279136"/>
+            <a:ext cx="9987991" cy="682752"/>
           </a:xfrm>
           <a:prstGeom prst="rect">
             <a:avLst/>
@@ -35028,7 +34994,7 @@
       </p:sp>
       <p:pic>
         <p:nvPicPr>
-          <p:cNvPr id="9" name="mermaid diagram" descr="9bd98ac1668d421c.png"/>
+          <p:cNvPr id="9" name="mermaid diagram" descr="054ebe97ce9d4699.png"/>
           <p:cNvPicPr>
             <a:picLocks noChangeAspect="1"/>
           </p:cNvPicPr>
@@ -35042,8 +35008,8 @@
         </p:blipFill>
         <p:spPr>
           <a:xfrm>
-            <a:off x="2395385" y="1956816"/>
-            <a:ext cx="7400925" cy="3043237"/>
+            <a:off x="3459803" y="1956816"/>
+            <a:ext cx="5272087" cy="2300287"/>
           </a:xfrm>
           <a:prstGeom prst="rect">
             <a:avLst/>

</xml_diff>